<commit_message>
Office 模板换成新墨色 #38352F（OneHistory 统一配色 2026-10-23）
</commit_message>
<xml_diff>
--- a/z-Unused/b-Office/项目报告.pptx
+++ b/z-Unused/b-Office/项目报告.pptx
@@ -2481,7 +2481,7 @@
     <p:bg>
       <p:bgPr>
         <a:solidFill>
-          <a:srgbClr val="26231E"/>
+          <a:srgbClr val="38352F"/>
         </a:solidFill>
       </p:bgPr>
     </p:bg>
@@ -2609,7 +2609,7 @@
             <a:lvl1pPr>
               <a:defRPr sz="1200">
                 <a:solidFill>
-                  <a:srgbClr val="26231E"/>
+                  <a:srgbClr val="38352F"/>
                 </a:solidFill>
                 <a:latin typeface="Bahnschrift"/>
                 <a:ea typeface="Bahnschrift"/>
@@ -2682,7 +2682,7 @@
             <a:lvl1pPr>
               <a:defRPr sz="1200">
                 <a:solidFill>
-                  <a:srgbClr val="26231E"/>
+                  <a:srgbClr val="38352F"/>
                 </a:solidFill>
                 <a:latin typeface="Bahnschrift"/>
                 <a:ea typeface="Bahnschrift"/>
@@ -3021,11 +3021,11 @@
             </a:avLst>
           </a:prstGeom>
           <a:solidFill>
-            <a:srgbClr val="26231E"/>
+            <a:srgbClr val="38352F"/>
           </a:solidFill>
           <a:ln w="12700">
             <a:solidFill>
-              <a:srgbClr val="26231E"/>
+              <a:srgbClr val="38352F"/>
             </a:solidFill>
             <a:prstDash val="solid"/>
           </a:ln>
@@ -3058,7 +3058,7 @@
             <a:r>
               <a:rPr lang="en-US" sz="1400" b="1" spc="400" kern="0" dirty="0">
                 <a:solidFill>
-                  <a:srgbClr val="26231E"/>
+                  <a:srgbClr val="38352F"/>
                 </a:solidFill>
                 <a:latin typeface="Bahnschrift" pitchFamily="34" charset="0"/>
                 <a:ea typeface="Bahnschrift" pitchFamily="34" charset="-122"/>
@@ -3097,7 +3097,7 @@
             <a:r>
               <a:rPr lang="en-US" sz="4800" b="1" dirty="0">
                 <a:solidFill>
-                  <a:srgbClr val="26231E"/>
+                  <a:srgbClr val="38352F"/>
                 </a:solidFill>
                 <a:latin typeface="Microsoft YaHei" pitchFamily="34" charset="0"/>
                 <a:ea typeface="Microsoft YaHei" pitchFamily="34" charset="-122"/>
@@ -3136,7 +3136,7 @@
             <a:r>
               <a:rPr lang="en-US" sz="2000" dirty="0">
                 <a:solidFill>
-                  <a:srgbClr val="6A6458"/>
+                  <a:srgbClr val="38352F"/>
                 </a:solidFill>
                 <a:latin typeface="Microsoft YaHei" pitchFamily="34" charset="0"/>
                 <a:ea typeface="Microsoft YaHei" pitchFamily="34" charset="-122"/>
@@ -3163,11 +3163,11 @@
             <a:avLst/>
           </a:prstGeom>
           <a:solidFill>
-            <a:srgbClr val="26231E"/>
+            <a:srgbClr val="38352F"/>
           </a:solidFill>
           <a:ln w="12700">
             <a:solidFill>
-              <a:srgbClr val="26231E"/>
+              <a:srgbClr val="38352F"/>
             </a:solidFill>
             <a:prstDash val="solid"/>
           </a:ln>
@@ -3200,7 +3200,7 @@
             <a:r>
               <a:rPr lang="en-US" sz="1100" dirty="0">
                 <a:solidFill>
-                  <a:srgbClr val="6A6458"/>
+                  <a:srgbClr val="38352F"/>
                 </a:solidFill>
                 <a:latin typeface="Microsoft YaHei" pitchFamily="34" charset="0"/>
                 <a:ea typeface="Microsoft YaHei" pitchFamily="34" charset="-122"/>
@@ -3239,7 +3239,7 @@
             <a:r>
               <a:rPr lang="en-US" sz="1800" b="1" dirty="0">
                 <a:solidFill>
-                  <a:srgbClr val="6A6458"/>
+                  <a:srgbClr val="38352F"/>
                 </a:solidFill>
                 <a:latin typeface="Microsoft YaHei" pitchFamily="34" charset="0"/>
                 <a:ea typeface="Microsoft YaHei" pitchFamily="34" charset="-122"/>
@@ -3301,7 +3301,7 @@
             <a:r>
               <a:rPr lang="en-US" sz="1100" dirty="0">
                 <a:solidFill>
-                  <a:srgbClr val="6A6458"/>
+                  <a:srgbClr val="38352F"/>
                 </a:solidFill>
                 <a:latin typeface="Microsoft YaHei" pitchFamily="34" charset="0"/>
                 <a:ea typeface="Microsoft YaHei" pitchFamily="34" charset="-122"/>
@@ -3340,7 +3340,7 @@
             <a:r>
               <a:rPr lang="en-US" sz="1800" b="1" dirty="0">
                 <a:solidFill>
-                  <a:srgbClr val="26231E"/>
+                  <a:srgbClr val="38352F"/>
                 </a:solidFill>
                 <a:latin typeface="Bahnschrift" pitchFamily="34" charset="0"/>
                 <a:ea typeface="Bahnschrift" pitchFamily="34" charset="-122"/>
@@ -3402,7 +3402,7 @@
             <a:r>
               <a:rPr lang="en-US" sz="1100" dirty="0">
                 <a:solidFill>
-                  <a:srgbClr val="6A6458"/>
+                  <a:srgbClr val="38352F"/>
                 </a:solidFill>
                 <a:latin typeface="Microsoft YaHei" pitchFamily="34" charset="0"/>
                 <a:ea typeface="Microsoft YaHei" pitchFamily="34" charset="-122"/>
@@ -3441,7 +3441,7 @@
             <a:r>
               <a:rPr lang="en-US" sz="1800" b="1" dirty="0">
                 <a:solidFill>
-                  <a:srgbClr val="26231E"/>
+                  <a:srgbClr val="38352F"/>
                 </a:solidFill>
                 <a:latin typeface="Bahnschrift" pitchFamily="34" charset="0"/>
                 <a:ea typeface="Bahnschrift" pitchFamily="34" charset="-122"/>
@@ -3468,11 +3468,11 @@
             <a:avLst/>
           </a:prstGeom>
           <a:solidFill>
-            <a:srgbClr val="26231E"/>
+            <a:srgbClr val="38352F"/>
           </a:solidFill>
           <a:ln w="12700">
             <a:solidFill>
-              <a:srgbClr val="26231E"/>
+              <a:srgbClr val="38352F"/>
             </a:solidFill>
             <a:prstDash val="solid"/>
           </a:ln>
@@ -3530,7 +3530,7 @@
             <a:r>
               <a:rPr lang="en-US" sz="2800" b="1" dirty="0">
                 <a:solidFill>
-                  <a:srgbClr val="26231E"/>
+                  <a:srgbClr val="38352F"/>
                 </a:solidFill>
                 <a:latin typeface="Microsoft YaHei" pitchFamily="34" charset="0"/>
                 <a:ea typeface="Microsoft YaHei" pitchFamily="34" charset="-122"/>
@@ -3559,11 +3559,11 @@
             </a:avLst>
           </a:prstGeom>
           <a:solidFill>
-            <a:srgbClr val="26231E"/>
+            <a:srgbClr val="38352F"/>
           </a:solidFill>
           <a:ln w="12700">
             <a:solidFill>
-              <a:srgbClr val="26231E"/>
+              <a:srgbClr val="38352F"/>
             </a:solidFill>
             <a:prstDash val="solid"/>
           </a:ln>
@@ -3637,11 +3637,11 @@
             <a:avLst/>
           </a:prstGeom>
           <a:solidFill>
-            <a:srgbClr val="26231E"/>
+            <a:srgbClr val="38352F"/>
           </a:solidFill>
           <a:ln w="12700">
             <a:solidFill>
-              <a:srgbClr val="26231E"/>
+              <a:srgbClr val="38352F"/>
             </a:solidFill>
             <a:prstDash val="solid"/>
           </a:ln>
@@ -3674,7 +3674,7 @@
             <a:r>
               <a:rPr lang="en-US" sz="1600" b="1" dirty="0">
                 <a:solidFill>
-                  <a:srgbClr val="26231E"/>
+                  <a:srgbClr val="38352F"/>
                 </a:solidFill>
                 <a:latin typeface="Bahnschrift" pitchFamily="34" charset="0"/>
                 <a:ea typeface="Bahnschrift" pitchFamily="34" charset="-122"/>
@@ -3713,7 +3713,7 @@
             <a:r>
               <a:rPr lang="en-US" sz="1800" b="1" dirty="0">
                 <a:solidFill>
-                  <a:srgbClr val="26231E"/>
+                  <a:srgbClr val="38352F"/>
                 </a:solidFill>
                 <a:latin typeface="Microsoft YaHei" pitchFamily="34" charset="0"/>
                 <a:ea typeface="Microsoft YaHei" pitchFamily="34" charset="-122"/>
@@ -3755,7 +3755,7 @@
             <a:r>
               <a:rPr lang="en-US" sz="1300" dirty="0">
                 <a:solidFill>
-                  <a:srgbClr val="6A6458"/>
+                  <a:srgbClr val="38352F"/>
                 </a:solidFill>
                 <a:latin typeface="Microsoft YaHei" pitchFamily="34" charset="0"/>
                 <a:ea typeface="Microsoft YaHei" pitchFamily="34" charset="-122"/>
@@ -3782,11 +3782,11 @@
             <a:avLst/>
           </a:prstGeom>
           <a:solidFill>
-            <a:srgbClr val="26231E"/>
+            <a:srgbClr val="38352F"/>
           </a:solidFill>
           <a:ln w="12700">
             <a:solidFill>
-              <a:srgbClr val="26231E"/>
+              <a:srgbClr val="38352F"/>
             </a:solidFill>
             <a:prstDash val="solid"/>
           </a:ln>
@@ -3819,7 +3819,7 @@
             <a:r>
               <a:rPr lang="en-US" sz="1600" b="1" dirty="0">
                 <a:solidFill>
-                  <a:srgbClr val="26231E"/>
+                  <a:srgbClr val="38352F"/>
                 </a:solidFill>
                 <a:latin typeface="Bahnschrift" pitchFamily="34" charset="0"/>
                 <a:ea typeface="Bahnschrift" pitchFamily="34" charset="-122"/>
@@ -3858,7 +3858,7 @@
             <a:r>
               <a:rPr lang="en-US" sz="1800" b="1" dirty="0">
                 <a:solidFill>
-                  <a:srgbClr val="26231E"/>
+                  <a:srgbClr val="38352F"/>
                 </a:solidFill>
                 <a:latin typeface="Microsoft YaHei" pitchFamily="34" charset="0"/>
                 <a:ea typeface="Microsoft YaHei" pitchFamily="34" charset="-122"/>
@@ -3900,7 +3900,7 @@
             <a:r>
               <a:rPr lang="en-US" sz="1300" dirty="0">
                 <a:solidFill>
-                  <a:srgbClr val="6A6458"/>
+                  <a:srgbClr val="38352F"/>
                 </a:solidFill>
                 <a:latin typeface="Microsoft YaHei" pitchFamily="34" charset="0"/>
                 <a:ea typeface="Microsoft YaHei" pitchFamily="34" charset="-122"/>
@@ -3927,11 +3927,11 @@
             <a:avLst/>
           </a:prstGeom>
           <a:solidFill>
-            <a:srgbClr val="26231E"/>
+            <a:srgbClr val="38352F"/>
           </a:solidFill>
           <a:ln w="12700">
             <a:solidFill>
-              <a:srgbClr val="26231E"/>
+              <a:srgbClr val="38352F"/>
             </a:solidFill>
             <a:prstDash val="solid"/>
           </a:ln>
@@ -3964,7 +3964,7 @@
             <a:r>
               <a:rPr lang="en-US" sz="1600" b="1" dirty="0">
                 <a:solidFill>
-                  <a:srgbClr val="26231E"/>
+                  <a:srgbClr val="38352F"/>
                 </a:solidFill>
                 <a:latin typeface="Bahnschrift" pitchFamily="34" charset="0"/>
                 <a:ea typeface="Bahnschrift" pitchFamily="34" charset="-122"/>
@@ -4003,7 +4003,7 @@
             <a:r>
               <a:rPr lang="en-US" sz="1800" b="1" dirty="0">
                 <a:solidFill>
-                  <a:srgbClr val="26231E"/>
+                  <a:srgbClr val="38352F"/>
                 </a:solidFill>
                 <a:latin typeface="Microsoft YaHei" pitchFamily="34" charset="0"/>
                 <a:ea typeface="Microsoft YaHei" pitchFamily="34" charset="-122"/>
@@ -4045,7 +4045,7 @@
             <a:r>
               <a:rPr lang="en-US" sz="1300" dirty="0">
                 <a:solidFill>
-                  <a:srgbClr val="6A6458"/>
+                  <a:srgbClr val="38352F"/>
                 </a:solidFill>
                 <a:latin typeface="Microsoft YaHei" pitchFamily="34" charset="0"/>
                 <a:ea typeface="Microsoft YaHei" pitchFamily="34" charset="-122"/>
@@ -4072,11 +4072,11 @@
             <a:avLst/>
           </a:prstGeom>
           <a:solidFill>
-            <a:srgbClr val="26231E"/>
+            <a:srgbClr val="38352F"/>
           </a:solidFill>
           <a:ln w="12700">
             <a:solidFill>
-              <a:srgbClr val="26231E"/>
+              <a:srgbClr val="38352F"/>
             </a:solidFill>
             <a:prstDash val="solid"/>
           </a:ln>
@@ -4109,7 +4109,7 @@
             <a:r>
               <a:rPr lang="en-US" sz="1600" b="1" dirty="0">
                 <a:solidFill>
-                  <a:srgbClr val="26231E"/>
+                  <a:srgbClr val="38352F"/>
                 </a:solidFill>
                 <a:latin typeface="Bahnschrift" pitchFamily="34" charset="0"/>
                 <a:ea typeface="Bahnschrift" pitchFamily="34" charset="-122"/>
@@ -4148,7 +4148,7 @@
             <a:r>
               <a:rPr lang="en-US" sz="1800" b="1" dirty="0">
                 <a:solidFill>
-                  <a:srgbClr val="26231E"/>
+                  <a:srgbClr val="38352F"/>
                 </a:solidFill>
                 <a:latin typeface="Microsoft YaHei" pitchFamily="34" charset="0"/>
                 <a:ea typeface="Microsoft YaHei" pitchFamily="34" charset="-122"/>
@@ -4190,7 +4190,7 @@
             <a:r>
               <a:rPr lang="en-US" sz="1300" dirty="0">
                 <a:solidFill>
-                  <a:srgbClr val="6A6458"/>
+                  <a:srgbClr val="38352F"/>
                 </a:solidFill>
                 <a:latin typeface="Microsoft YaHei" pitchFamily="34" charset="0"/>
                 <a:ea typeface="Microsoft YaHei" pitchFamily="34" charset="-122"/>
@@ -4232,7 +4232,7 @@
             <a:lvl1pPr>
               <a:defRPr sz="1200">
                 <a:solidFill>
-                  <a:srgbClr val="26231E"/>
+                  <a:srgbClr val="38352F"/>
                 </a:solidFill>
                 <a:latin typeface="Bahnschrift"/>
                 <a:ea typeface="Bahnschrift"/>
@@ -4302,7 +4302,7 @@
             <a:r>
               <a:rPr lang="en-US" sz="2800" b="1" dirty="0">
                 <a:solidFill>
-                  <a:srgbClr val="26231E"/>
+                  <a:srgbClr val="38352F"/>
                 </a:solidFill>
                 <a:latin typeface="Microsoft YaHei" pitchFamily="34" charset="0"/>
                 <a:ea typeface="Microsoft YaHei" pitchFamily="34" charset="-122"/>
@@ -4331,11 +4331,11 @@
             </a:avLst>
           </a:prstGeom>
           <a:solidFill>
-            <a:srgbClr val="26231E"/>
+            <a:srgbClr val="38352F"/>
           </a:solidFill>
           <a:ln w="12700">
             <a:solidFill>
-              <a:srgbClr val="26231E"/>
+              <a:srgbClr val="38352F"/>
             </a:solidFill>
             <a:prstDash val="solid"/>
           </a:ln>
@@ -4409,11 +4409,11 @@
             <a:avLst/>
           </a:prstGeom>
           <a:solidFill>
-            <a:srgbClr val="26231E"/>
+            <a:srgbClr val="38352F"/>
           </a:solidFill>
           <a:ln w="12700">
             <a:solidFill>
-              <a:srgbClr val="26231E"/>
+              <a:srgbClr val="38352F"/>
             </a:solidFill>
             <a:prstDash val="solid"/>
           </a:ln>
@@ -4446,7 +4446,7 @@
             <a:r>
               <a:rPr lang="en-US" sz="1800" b="1" dirty="0">
                 <a:solidFill>
-                  <a:srgbClr val="26231E"/>
+                  <a:srgbClr val="38352F"/>
                 </a:solidFill>
                 <a:latin typeface="Microsoft YaHei" pitchFamily="34" charset="0"/>
                 <a:ea typeface="Microsoft YaHei" pitchFamily="34" charset="-122"/>
@@ -4460,7 +4460,7 @@
             <a:r>
               <a:rPr lang="en-US" sz="1200" dirty="0">
                 <a:solidFill>
-                  <a:srgbClr val="6A6458"/>
+                  <a:srgbClr val="38352F"/>
                 </a:solidFill>
                 <a:latin typeface="Bahnschrift" pitchFamily="34" charset="0"/>
                 <a:ea typeface="Bahnschrift" pitchFamily="34" charset="-122"/>
@@ -4526,7 +4526,7 @@
             <a:r>
               <a:rPr lang="en-US" sz="1200" dirty="0">
                 <a:solidFill>
-                  <a:srgbClr val="6A6458"/>
+                  <a:srgbClr val="38352F"/>
                 </a:solidFill>
                 <a:latin typeface="Microsoft YaHei" pitchFamily="34" charset="0"/>
                 <a:ea typeface="Microsoft YaHei" pitchFamily="34" charset="-122"/>
@@ -4569,7 +4569,7 @@
             <a:r>
               <a:rPr lang="en-US" sz="1400" dirty="0">
                 <a:solidFill>
-                  <a:srgbClr val="26231E"/>
+                  <a:srgbClr val="38352F"/>
                 </a:solidFill>
                 <a:latin typeface="Microsoft YaHei" pitchFamily="34" charset="0"/>
                 <a:ea typeface="Microsoft YaHei" pitchFamily="34" charset="-122"/>
@@ -4590,7 +4590,7 @@
             <a:r>
               <a:rPr lang="en-US" sz="1400" dirty="0">
                 <a:solidFill>
-                  <a:srgbClr val="26231E"/>
+                  <a:srgbClr val="38352F"/>
                 </a:solidFill>
                 <a:latin typeface="Microsoft YaHei" pitchFamily="34" charset="0"/>
                 <a:ea typeface="Microsoft YaHei" pitchFamily="34" charset="-122"/>
@@ -4617,11 +4617,11 @@
             <a:avLst/>
           </a:prstGeom>
           <a:solidFill>
-            <a:srgbClr val="26231E"/>
+            <a:srgbClr val="38352F"/>
           </a:solidFill>
           <a:ln w="12700">
             <a:solidFill>
-              <a:srgbClr val="26231E"/>
+              <a:srgbClr val="38352F"/>
             </a:solidFill>
             <a:prstDash val="solid"/>
           </a:ln>
@@ -4654,7 +4654,7 @@
             <a:r>
               <a:rPr lang="en-US" sz="1800" b="1" dirty="0">
                 <a:solidFill>
-                  <a:srgbClr val="26231E"/>
+                  <a:srgbClr val="38352F"/>
                 </a:solidFill>
                 <a:latin typeface="Microsoft YaHei" pitchFamily="34" charset="0"/>
                 <a:ea typeface="Microsoft YaHei" pitchFamily="34" charset="-122"/>
@@ -4668,7 +4668,7 @@
             <a:r>
               <a:rPr lang="en-US" sz="1200" dirty="0">
                 <a:solidFill>
-                  <a:srgbClr val="6A6458"/>
+                  <a:srgbClr val="38352F"/>
                 </a:solidFill>
                 <a:latin typeface="Bahnschrift" pitchFamily="34" charset="0"/>
                 <a:ea typeface="Bahnschrift" pitchFamily="34" charset="-122"/>
@@ -4701,7 +4701,7 @@
           </a:solidFill>
           <a:ln w="19050">
             <a:solidFill>
-              <a:srgbClr val="26231E"/>
+              <a:srgbClr val="38352F"/>
             </a:solidFill>
             <a:prstDash val="solid"/>
           </a:ln>
@@ -4734,7 +4734,7 @@
             <a:r>
               <a:rPr lang="en-US" sz="1200" dirty="0">
                 <a:solidFill>
-                  <a:srgbClr val="6A6458"/>
+                  <a:srgbClr val="38352F"/>
                 </a:solidFill>
                 <a:latin typeface="Microsoft YaHei" pitchFamily="34" charset="0"/>
                 <a:ea typeface="Microsoft YaHei" pitchFamily="34" charset="-122"/>
@@ -4777,7 +4777,7 @@
             <a:r>
               <a:rPr lang="en-US" sz="1400" dirty="0">
                 <a:solidFill>
-                  <a:srgbClr val="26231E"/>
+                  <a:srgbClr val="38352F"/>
                 </a:solidFill>
                 <a:latin typeface="Microsoft YaHei" pitchFamily="34" charset="0"/>
                 <a:ea typeface="Microsoft YaHei" pitchFamily="34" charset="-122"/>
@@ -4798,7 +4798,7 @@
             <a:r>
               <a:rPr lang="en-US" sz="1400" dirty="0">
                 <a:solidFill>
-                  <a:srgbClr val="26231E"/>
+                  <a:srgbClr val="38352F"/>
                 </a:solidFill>
                 <a:latin typeface="Microsoft YaHei" pitchFamily="34" charset="0"/>
                 <a:ea typeface="Microsoft YaHei" pitchFamily="34" charset="-122"/>
@@ -4840,7 +4840,7 @@
             <a:lvl1pPr>
               <a:defRPr sz="1200">
                 <a:solidFill>
-                  <a:srgbClr val="26231E"/>
+                  <a:srgbClr val="38352F"/>
                 </a:solidFill>
                 <a:latin typeface="Bahnschrift"/>
                 <a:ea typeface="Bahnschrift"/>
@@ -4988,7 +4988,7 @@
             <a:r>
               <a:rPr lang="en-US" sz="1800" dirty="0">
                 <a:solidFill>
-                  <a:srgbClr val="ACA593"/>
+                  <a:srgbClr val="DAD7CE"/>
                 </a:solidFill>
                 <a:latin typeface="Microsoft YaHei" pitchFamily="34" charset="0"/>
                 <a:ea typeface="Microsoft YaHei" pitchFamily="34" charset="-122"/>
@@ -5027,7 +5027,7 @@
             <a:r>
               <a:rPr lang="en-US" sz="1200" dirty="0">
                 <a:solidFill>
-                  <a:srgbClr val="ACA593"/>
+                  <a:srgbClr val="DAD7CE"/>
                 </a:solidFill>
                 <a:latin typeface="Bahnschrift" pitchFamily="34" charset="0"/>
                 <a:ea typeface="Bahnschrift" pitchFamily="34" charset="-122"/>
@@ -5091,7 +5091,7 @@
             <a:r>
               <a:rPr lang="en-US" sz="2800" b="1" dirty="0">
                 <a:solidFill>
-                  <a:srgbClr val="26231E"/>
+                  <a:srgbClr val="38352F"/>
                 </a:solidFill>
                 <a:latin typeface="Microsoft YaHei" pitchFamily="34" charset="0"/>
                 <a:ea typeface="Microsoft YaHei" pitchFamily="34" charset="-122"/>
@@ -5120,11 +5120,11 @@
             </a:avLst>
           </a:prstGeom>
           <a:solidFill>
-            <a:srgbClr val="26231E"/>
+            <a:srgbClr val="38352F"/>
           </a:solidFill>
           <a:ln w="12700">
             <a:solidFill>
-              <a:srgbClr val="26231E"/>
+              <a:srgbClr val="38352F"/>
             </a:solidFill>
             <a:prstDash val="solid"/>
           </a:ln>
@@ -5224,7 +5224,7 @@
                       <a:r>
                         <a:rPr lang="en-US" sz="1300" b="1" dirty="0">
                           <a:solidFill>
-                            <a:srgbClr val="26231E"/>
+                            <a:srgbClr val="38352F"/>
                           </a:solidFill>
                           <a:latin typeface="Microsoft YaHei" pitchFamily="34" charset="0"/>
                           <a:ea typeface="Microsoft YaHei" pitchFamily="34" charset="-122"/>
@@ -5248,7 +5248,7 @@
                     </a:lnR>
                     <a:lnT w="28575" cap="flat" cmpd="sng" algn="ctr">
                       <a:solidFill>
-                        <a:srgbClr val="26231E"/>
+                        <a:srgbClr val="38352F"/>
                       </a:solidFill>
                       <a:prstDash val="solid"/>
                       <a:round/>
@@ -5257,7 +5257,7 @@
                     </a:lnT>
                     <a:lnB w="9525" cap="flat" cmpd="sng" algn="ctr">
                       <a:solidFill>
-                        <a:srgbClr val="26231E"/>
+                        <a:srgbClr val="38352F"/>
                       </a:solidFill>
                       <a:prstDash val="solid"/>
                       <a:round/>
@@ -5277,7 +5277,7 @@
                       <a:r>
                         <a:rPr lang="en-US" sz="1300" b="1" dirty="0">
                           <a:solidFill>
-                            <a:srgbClr val="26231E"/>
+                            <a:srgbClr val="38352F"/>
                           </a:solidFill>
                           <a:latin typeface="Microsoft YaHei" pitchFamily="34" charset="0"/>
                           <a:ea typeface="Microsoft YaHei" pitchFamily="34" charset="-122"/>
@@ -5301,7 +5301,7 @@
                     </a:lnR>
                     <a:lnT w="28575" cap="flat" cmpd="sng" algn="ctr">
                       <a:solidFill>
-                        <a:srgbClr val="26231E"/>
+                        <a:srgbClr val="38352F"/>
                       </a:solidFill>
                       <a:prstDash val="solid"/>
                       <a:round/>
@@ -5310,7 +5310,7 @@
                     </a:lnT>
                     <a:lnB w="9525" cap="flat" cmpd="sng" algn="ctr">
                       <a:solidFill>
-                        <a:srgbClr val="26231E"/>
+                        <a:srgbClr val="38352F"/>
                       </a:solidFill>
                       <a:prstDash val="solid"/>
                       <a:round/>
@@ -5330,7 +5330,7 @@
                       <a:r>
                         <a:rPr lang="en-US" sz="1300" b="1" dirty="0">
                           <a:solidFill>
-                            <a:srgbClr val="26231E"/>
+                            <a:srgbClr val="38352F"/>
                           </a:solidFill>
                           <a:latin typeface="Microsoft YaHei" pitchFamily="34" charset="0"/>
                           <a:ea typeface="Microsoft YaHei" pitchFamily="34" charset="-122"/>
@@ -5354,7 +5354,7 @@
                     </a:lnR>
                     <a:lnT w="28575" cap="flat" cmpd="sng" algn="ctr">
                       <a:solidFill>
-                        <a:srgbClr val="26231E"/>
+                        <a:srgbClr val="38352F"/>
                       </a:solidFill>
                       <a:prstDash val="solid"/>
                       <a:round/>
@@ -5363,7 +5363,7 @@
                     </a:lnT>
                     <a:lnB w="9525" cap="flat" cmpd="sng" algn="ctr">
                       <a:solidFill>
-                        <a:srgbClr val="26231E"/>
+                        <a:srgbClr val="38352F"/>
                       </a:solidFill>
                       <a:prstDash val="solid"/>
                       <a:round/>
@@ -5383,7 +5383,7 @@
                       <a:r>
                         <a:rPr lang="en-US" sz="1300" b="1" dirty="0">
                           <a:solidFill>
-                            <a:srgbClr val="26231E"/>
+                            <a:srgbClr val="38352F"/>
                           </a:solidFill>
                           <a:latin typeface="Microsoft YaHei" pitchFamily="34" charset="0"/>
                           <a:ea typeface="Microsoft YaHei" pitchFamily="34" charset="-122"/>
@@ -5407,7 +5407,7 @@
                     </a:lnR>
                     <a:lnT w="28575" cap="flat" cmpd="sng" algn="ctr">
                       <a:solidFill>
-                        <a:srgbClr val="26231E"/>
+                        <a:srgbClr val="38352F"/>
                       </a:solidFill>
                       <a:prstDash val="solid"/>
                       <a:round/>
@@ -5416,7 +5416,7 @@
                     </a:lnT>
                     <a:lnB w="9525" cap="flat" cmpd="sng" algn="ctr">
                       <a:solidFill>
-                        <a:srgbClr val="26231E"/>
+                        <a:srgbClr val="38352F"/>
                       </a:solidFill>
                       <a:prstDash val="solid"/>
                       <a:round/>
@@ -5436,7 +5436,7 @@
                       <a:r>
                         <a:rPr lang="en-US" sz="1300" b="1" dirty="0">
                           <a:solidFill>
-                            <a:srgbClr val="26231E"/>
+                            <a:srgbClr val="38352F"/>
                           </a:solidFill>
                           <a:latin typeface="Microsoft YaHei" pitchFamily="34" charset="0"/>
                           <a:ea typeface="Microsoft YaHei" pitchFamily="34" charset="-122"/>
@@ -5460,7 +5460,7 @@
                     </a:lnR>
                     <a:lnT w="28575" cap="flat" cmpd="sng" algn="ctr">
                       <a:solidFill>
-                        <a:srgbClr val="26231E"/>
+                        <a:srgbClr val="38352F"/>
                       </a:solidFill>
                       <a:prstDash val="solid"/>
                       <a:round/>
@@ -5469,7 +5469,7 @@
                     </a:lnT>
                     <a:lnB w="9525" cap="flat" cmpd="sng" algn="ctr">
                       <a:solidFill>
-                        <a:srgbClr val="26231E"/>
+                        <a:srgbClr val="38352F"/>
                       </a:solidFill>
                       <a:prstDash val="solid"/>
                       <a:round/>
@@ -5491,7 +5491,7 @@
                       <a:r>
                         <a:rPr lang="en-US" sz="1400" dirty="0">
                           <a:solidFill>
-                            <a:srgbClr val="6A6458"/>
+                            <a:srgbClr val="38352F"/>
                           </a:solidFill>
                           <a:latin typeface="Microsoft YaHei" pitchFamily="34" charset="0"/>
                           <a:ea typeface="Microsoft YaHei" pitchFamily="34" charset="-122"/>
@@ -5538,7 +5538,7 @@
                       <a:r>
                         <a:rPr lang="en-US" sz="1400" dirty="0">
                           <a:solidFill>
-                            <a:srgbClr val="6A6458"/>
+                            <a:srgbClr val="38352F"/>
                           </a:solidFill>
                           <a:latin typeface="Microsoft YaHei" pitchFamily="34" charset="0"/>
                           <a:ea typeface="Microsoft YaHei" pitchFamily="34" charset="-122"/>
@@ -5585,7 +5585,7 @@
                       <a:r>
                         <a:rPr lang="en-US" sz="1400" dirty="0">
                           <a:solidFill>
-                            <a:srgbClr val="6A6458"/>
+                            <a:srgbClr val="38352F"/>
                           </a:solidFill>
                           <a:latin typeface="Microsoft YaHei" pitchFamily="34" charset="0"/>
                           <a:ea typeface="Microsoft YaHei" pitchFamily="34" charset="-122"/>
@@ -5632,7 +5632,7 @@
                       <a:r>
                         <a:rPr lang="en-US" sz="1400" dirty="0">
                           <a:solidFill>
-                            <a:srgbClr val="6A6458"/>
+                            <a:srgbClr val="38352F"/>
                           </a:solidFill>
                           <a:latin typeface="Microsoft YaHei" pitchFamily="34" charset="0"/>
                           <a:ea typeface="Microsoft YaHei" pitchFamily="34" charset="-122"/>
@@ -5679,7 +5679,7 @@
                       <a:r>
                         <a:rPr lang="en-US" sz="1400" dirty="0">
                           <a:solidFill>
-                            <a:srgbClr val="26231E"/>
+                            <a:srgbClr val="38352F"/>
                           </a:solidFill>
                           <a:latin typeface="Microsoft YaHei" pitchFamily="34" charset="0"/>
                           <a:ea typeface="Microsoft YaHei" pitchFamily="34" charset="-122"/>
@@ -5728,7 +5728,7 @@
                       <a:r>
                         <a:rPr lang="en-US" sz="1400" dirty="0">
                           <a:solidFill>
-                            <a:srgbClr val="6A6458"/>
+                            <a:srgbClr val="38352F"/>
                           </a:solidFill>
                           <a:latin typeface="Microsoft YaHei" pitchFamily="34" charset="0"/>
                           <a:ea typeface="Microsoft YaHei" pitchFamily="34" charset="-122"/>
@@ -5775,7 +5775,7 @@
                       <a:r>
                         <a:rPr lang="en-US" sz="1400" dirty="0">
                           <a:solidFill>
-                            <a:srgbClr val="6A6458"/>
+                            <a:srgbClr val="38352F"/>
                           </a:solidFill>
                           <a:latin typeface="Microsoft YaHei" pitchFamily="34" charset="0"/>
                           <a:ea typeface="Microsoft YaHei" pitchFamily="34" charset="-122"/>
@@ -5822,7 +5822,7 @@
                       <a:r>
                         <a:rPr lang="en-US" sz="1400" dirty="0">
                           <a:solidFill>
-                            <a:srgbClr val="6A6458"/>
+                            <a:srgbClr val="38352F"/>
                           </a:solidFill>
                           <a:latin typeface="Microsoft YaHei" pitchFamily="34" charset="0"/>
                           <a:ea typeface="Microsoft YaHei" pitchFamily="34" charset="-122"/>
@@ -5869,7 +5869,7 @@
                       <a:r>
                         <a:rPr lang="en-US" sz="1400" dirty="0">
                           <a:solidFill>
-                            <a:srgbClr val="6A6458"/>
+                            <a:srgbClr val="38352F"/>
                           </a:solidFill>
                           <a:latin typeface="Microsoft YaHei" pitchFamily="34" charset="0"/>
                           <a:ea typeface="Microsoft YaHei" pitchFamily="34" charset="-122"/>
@@ -5916,7 +5916,7 @@
                       <a:r>
                         <a:rPr lang="en-US" sz="1400" dirty="0">
                           <a:solidFill>
-                            <a:srgbClr val="26231E"/>
+                            <a:srgbClr val="38352F"/>
                           </a:solidFill>
                           <a:latin typeface="Microsoft YaHei" pitchFamily="34" charset="0"/>
                           <a:ea typeface="Microsoft YaHei" pitchFamily="34" charset="-122"/>
@@ -5965,7 +5965,7 @@
                       <a:r>
                         <a:rPr lang="en-US" sz="1400" dirty="0">
                           <a:solidFill>
-                            <a:srgbClr val="6A6458"/>
+                            <a:srgbClr val="38352F"/>
                           </a:solidFill>
                           <a:latin typeface="Microsoft YaHei" pitchFamily="34" charset="0"/>
                           <a:ea typeface="Microsoft YaHei" pitchFamily="34" charset="-122"/>
@@ -5992,7 +5992,7 @@
                     </a:lnT>
                     <a:lnB w="12700" cap="flat" cmpd="sng" algn="ctr">
                       <a:solidFill>
-                        <a:srgbClr val="26231E"/>
+                        <a:srgbClr val="38352F"/>
                       </a:solidFill>
                       <a:prstDash val="solid"/>
                       <a:round/>
@@ -6012,7 +6012,7 @@
                       <a:r>
                         <a:rPr lang="en-US" sz="1400" dirty="0">
                           <a:solidFill>
-                            <a:srgbClr val="6A6458"/>
+                            <a:srgbClr val="38352F"/>
                           </a:solidFill>
                           <a:latin typeface="Microsoft YaHei" pitchFamily="34" charset="0"/>
                           <a:ea typeface="Microsoft YaHei" pitchFamily="34" charset="-122"/>
@@ -6039,7 +6039,7 @@
                     </a:lnT>
                     <a:lnB w="12700" cap="flat" cmpd="sng" algn="ctr">
                       <a:solidFill>
-                        <a:srgbClr val="26231E"/>
+                        <a:srgbClr val="38352F"/>
                       </a:solidFill>
                       <a:prstDash val="solid"/>
                       <a:round/>
@@ -6059,7 +6059,7 @@
                       <a:r>
                         <a:rPr lang="en-US" sz="1400" dirty="0">
                           <a:solidFill>
-                            <a:srgbClr val="6A6458"/>
+                            <a:srgbClr val="38352F"/>
                           </a:solidFill>
                           <a:latin typeface="Microsoft YaHei" pitchFamily="34" charset="0"/>
                           <a:ea typeface="Microsoft YaHei" pitchFamily="34" charset="-122"/>
@@ -6086,7 +6086,7 @@
                     </a:lnT>
                     <a:lnB w="12700" cap="flat" cmpd="sng" algn="ctr">
                       <a:solidFill>
-                        <a:srgbClr val="26231E"/>
+                        <a:srgbClr val="38352F"/>
                       </a:solidFill>
                       <a:prstDash val="solid"/>
                       <a:round/>
@@ -6106,7 +6106,7 @@
                       <a:r>
                         <a:rPr lang="en-US" sz="1400" dirty="0">
                           <a:solidFill>
-                            <a:srgbClr val="6A6458"/>
+                            <a:srgbClr val="38352F"/>
                           </a:solidFill>
                           <a:latin typeface="Microsoft YaHei" pitchFamily="34" charset="0"/>
                           <a:ea typeface="Microsoft YaHei" pitchFamily="34" charset="-122"/>
@@ -6133,7 +6133,7 @@
                     </a:lnT>
                     <a:lnB w="12700" cap="flat" cmpd="sng" algn="ctr">
                       <a:solidFill>
-                        <a:srgbClr val="26231E"/>
+                        <a:srgbClr val="38352F"/>
                       </a:solidFill>
                       <a:prstDash val="solid"/>
                       <a:round/>
@@ -6153,7 +6153,7 @@
                       <a:r>
                         <a:rPr lang="en-US" sz="1400" dirty="0">
                           <a:solidFill>
-                            <a:srgbClr val="26231E"/>
+                            <a:srgbClr val="38352F"/>
                           </a:solidFill>
                           <a:latin typeface="Microsoft YaHei" pitchFamily="34" charset="0"/>
                           <a:ea typeface="Microsoft YaHei" pitchFamily="34" charset="-122"/>
@@ -6180,7 +6180,7 @@
                     </a:lnT>
                     <a:lnB w="12700" cap="flat" cmpd="sng" algn="ctr">
                       <a:solidFill>
-                        <a:srgbClr val="26231E"/>
+                        <a:srgbClr val="38352F"/>
                       </a:solidFill>
                       <a:prstDash val="solid"/>
                       <a:round/>
@@ -6224,7 +6224,7 @@
             <a:lvl1pPr>
               <a:defRPr sz="1200">
                 <a:solidFill>
-                  <a:srgbClr val="26231E"/>
+                  <a:srgbClr val="38352F"/>
                 </a:solidFill>
                 <a:latin typeface="Bahnschrift"/>
                 <a:ea typeface="Bahnschrift"/>
@@ -6294,7 +6294,7 @@
             <a:r>
               <a:rPr lang="en-US" sz="2800" b="1" dirty="0">
                 <a:solidFill>
-                  <a:srgbClr val="26231E"/>
+                  <a:srgbClr val="38352F"/>
                 </a:solidFill>
                 <a:latin typeface="Microsoft YaHei" pitchFamily="34" charset="0"/>
                 <a:ea typeface="Microsoft YaHei" pitchFamily="34" charset="-122"/>
@@ -6323,11 +6323,11 @@
             </a:avLst>
           </a:prstGeom>
           <a:solidFill>
-            <a:srgbClr val="26231E"/>
+            <a:srgbClr val="38352F"/>
           </a:solidFill>
           <a:ln w="12700">
             <a:solidFill>
-              <a:srgbClr val="26231E"/>
+              <a:srgbClr val="38352F"/>
             </a:solidFill>
             <a:prstDash val="solid"/>
           </a:ln>
@@ -6440,7 +6440,7 @@
             <a:r>
               <a:rPr lang="en-US" sz="1200" dirty="0">
                 <a:solidFill>
-                  <a:srgbClr val="6A6458"/>
+                  <a:srgbClr val="38352F"/>
                 </a:solidFill>
                 <a:latin typeface="Microsoft YaHei" pitchFamily="34" charset="0"/>
                 <a:ea typeface="Microsoft YaHei" pitchFamily="34" charset="-122"/>
@@ -6479,7 +6479,7 @@
             <a:r>
               <a:rPr lang="en-US" sz="2000" b="1" dirty="0">
                 <a:solidFill>
-                  <a:srgbClr val="26231E"/>
+                  <a:srgbClr val="38352F"/>
                 </a:solidFill>
                 <a:latin typeface="Microsoft YaHei" pitchFamily="34" charset="0"/>
                 <a:ea typeface="Microsoft YaHei" pitchFamily="34" charset="-122"/>
@@ -6550,7 +6550,7 @@
             <a:r>
               <a:rPr lang="en-US" sz="1400" dirty="0">
                 <a:solidFill>
-                  <a:srgbClr val="26231E"/>
+                  <a:srgbClr val="38352F"/>
                 </a:solidFill>
                 <a:latin typeface="Microsoft YaHei" pitchFamily="34" charset="0"/>
                 <a:ea typeface="Microsoft YaHei" pitchFamily="34" charset="-122"/>
@@ -6574,7 +6574,7 @@
             <a:r>
               <a:rPr lang="en-US" sz="1400" dirty="0">
                 <a:solidFill>
-                  <a:srgbClr val="26231E"/>
+                  <a:srgbClr val="38352F"/>
                 </a:solidFill>
                 <a:latin typeface="Microsoft YaHei" pitchFamily="34" charset="0"/>
                 <a:ea typeface="Microsoft YaHei" pitchFamily="34" charset="-122"/>
@@ -6598,7 +6598,7 @@
             <a:r>
               <a:rPr lang="en-US" sz="1400" dirty="0">
                 <a:solidFill>
-                  <a:srgbClr val="26231E"/>
+                  <a:srgbClr val="38352F"/>
                 </a:solidFill>
                 <a:latin typeface="Microsoft YaHei" pitchFamily="34" charset="0"/>
                 <a:ea typeface="Microsoft YaHei" pitchFamily="34" charset="-122"/>
@@ -6622,7 +6622,7 @@
             <a:r>
               <a:rPr lang="en-US" sz="1400" dirty="0">
                 <a:solidFill>
-                  <a:srgbClr val="26231E"/>
+                  <a:srgbClr val="38352F"/>
                 </a:solidFill>
                 <a:latin typeface="Microsoft YaHei" pitchFamily="34" charset="0"/>
                 <a:ea typeface="Microsoft YaHei" pitchFamily="34" charset="-122"/>
@@ -6664,7 +6664,7 @@
             <a:lvl1pPr>
               <a:defRPr sz="1200">
                 <a:solidFill>
-                  <a:srgbClr val="26231E"/>
+                  <a:srgbClr val="38352F"/>
                 </a:solidFill>
                 <a:latin typeface="Bahnschrift"/>
                 <a:ea typeface="Bahnschrift"/>
@@ -6734,7 +6734,7 @@
             <a:r>
               <a:rPr lang="en-US" sz="2800" b="1" dirty="0">
                 <a:solidFill>
-                  <a:srgbClr val="26231E"/>
+                  <a:srgbClr val="38352F"/>
                 </a:solidFill>
                 <a:latin typeface="Microsoft YaHei" pitchFamily="34" charset="0"/>
                 <a:ea typeface="Microsoft YaHei" pitchFamily="34" charset="-122"/>
@@ -6763,11 +6763,11 @@
             </a:avLst>
           </a:prstGeom>
           <a:solidFill>
-            <a:srgbClr val="26231E"/>
+            <a:srgbClr val="38352F"/>
           </a:solidFill>
           <a:ln w="12700">
             <a:solidFill>
-              <a:srgbClr val="26231E"/>
+              <a:srgbClr val="38352F"/>
             </a:solidFill>
             <a:prstDash val="solid"/>
           </a:ln>
@@ -6880,7 +6880,7 @@
             <a:r>
               <a:rPr lang="en-US" sz="1800" b="1" dirty="0">
                 <a:solidFill>
-                  <a:srgbClr val="26231E"/>
+                  <a:srgbClr val="38352F"/>
                 </a:solidFill>
                 <a:latin typeface="Bahnschrift" pitchFamily="34" charset="0"/>
                 <a:ea typeface="Bahnschrift" pitchFamily="34" charset="-122"/>
@@ -6919,7 +6919,7 @@
             <a:r>
               <a:rPr lang="en-US" sz="2200" b="1" dirty="0">
                 <a:solidFill>
-                  <a:srgbClr val="26231E"/>
+                  <a:srgbClr val="38352F"/>
                 </a:solidFill>
                 <a:latin typeface="Microsoft YaHei" pitchFamily="34" charset="0"/>
                 <a:ea typeface="Microsoft YaHei" pitchFamily="34" charset="-122"/>
@@ -6958,7 +6958,7 @@
             <a:r>
               <a:rPr lang="en-US" sz="1300" dirty="0">
                 <a:solidFill>
-                  <a:srgbClr val="6A6458"/>
+                  <a:srgbClr val="38352F"/>
                 </a:solidFill>
                 <a:latin typeface="Microsoft YaHei" pitchFamily="34" charset="0"/>
                 <a:ea typeface="Microsoft YaHei" pitchFamily="34" charset="-122"/>
@@ -6997,7 +6997,7 @@
             <a:r>
               <a:rPr lang="en-US" sz="2200" dirty="0">
                 <a:solidFill>
-                  <a:srgbClr val="26231E"/>
+                  <a:srgbClr val="38352F"/>
                 </a:solidFill>
                 <a:latin typeface="Bahnschrift" pitchFamily="34" charset="0"/>
                 <a:ea typeface="Bahnschrift" pitchFamily="34" charset="-122"/>
@@ -7063,7 +7063,7 @@
             <a:r>
               <a:rPr lang="en-US" sz="1800" b="1" dirty="0">
                 <a:solidFill>
-                  <a:srgbClr val="26231E"/>
+                  <a:srgbClr val="38352F"/>
                 </a:solidFill>
                 <a:latin typeface="Bahnschrift" pitchFamily="34" charset="0"/>
                 <a:ea typeface="Bahnschrift" pitchFamily="34" charset="-122"/>
@@ -7102,7 +7102,7 @@
             <a:r>
               <a:rPr lang="en-US" sz="2200" b="1" dirty="0">
                 <a:solidFill>
-                  <a:srgbClr val="26231E"/>
+                  <a:srgbClr val="38352F"/>
                 </a:solidFill>
                 <a:latin typeface="Microsoft YaHei" pitchFamily="34" charset="0"/>
                 <a:ea typeface="Microsoft YaHei" pitchFamily="34" charset="-122"/>
@@ -7141,7 +7141,7 @@
             <a:r>
               <a:rPr lang="en-US" sz="1300" dirty="0">
                 <a:solidFill>
-                  <a:srgbClr val="6A6458"/>
+                  <a:srgbClr val="38352F"/>
                 </a:solidFill>
                 <a:latin typeface="Microsoft YaHei" pitchFamily="34" charset="0"/>
                 <a:ea typeface="Microsoft YaHei" pitchFamily="34" charset="-122"/>
@@ -7180,7 +7180,7 @@
             <a:r>
               <a:rPr lang="en-US" sz="2200" dirty="0">
                 <a:solidFill>
-                  <a:srgbClr val="26231E"/>
+                  <a:srgbClr val="38352F"/>
                 </a:solidFill>
                 <a:latin typeface="Bahnschrift" pitchFamily="34" charset="0"/>
                 <a:ea typeface="Bahnschrift" pitchFamily="34" charset="-122"/>
@@ -7246,7 +7246,7 @@
             <a:r>
               <a:rPr lang="en-US" sz="1800" b="1" dirty="0">
                 <a:solidFill>
-                  <a:srgbClr val="26231E"/>
+                  <a:srgbClr val="38352F"/>
                 </a:solidFill>
                 <a:latin typeface="Bahnschrift" pitchFamily="34" charset="0"/>
                 <a:ea typeface="Bahnschrift" pitchFamily="34" charset="-122"/>
@@ -7285,7 +7285,7 @@
             <a:r>
               <a:rPr lang="en-US" sz="2200" b="1" dirty="0">
                 <a:solidFill>
-                  <a:srgbClr val="26231E"/>
+                  <a:srgbClr val="38352F"/>
                 </a:solidFill>
                 <a:latin typeface="Microsoft YaHei" pitchFamily="34" charset="0"/>
                 <a:ea typeface="Microsoft YaHei" pitchFamily="34" charset="-122"/>
@@ -7324,7 +7324,7 @@
             <a:r>
               <a:rPr lang="en-US" sz="1300" dirty="0">
                 <a:solidFill>
-                  <a:srgbClr val="6A6458"/>
+                  <a:srgbClr val="38352F"/>
                 </a:solidFill>
                 <a:latin typeface="Microsoft YaHei" pitchFamily="34" charset="0"/>
                 <a:ea typeface="Microsoft YaHei" pitchFamily="34" charset="-122"/>
@@ -7363,7 +7363,7 @@
             <a:r>
               <a:rPr lang="en-US" sz="2200" dirty="0">
                 <a:solidFill>
-                  <a:srgbClr val="26231E"/>
+                  <a:srgbClr val="38352F"/>
                 </a:solidFill>
                 <a:latin typeface="Bahnschrift" pitchFamily="34" charset="0"/>
                 <a:ea typeface="Bahnschrift" pitchFamily="34" charset="-122"/>
@@ -7396,7 +7396,7 @@
           </a:solidFill>
           <a:ln w="28575">
             <a:solidFill>
-              <a:srgbClr val="26231E"/>
+              <a:srgbClr val="38352F"/>
             </a:solidFill>
             <a:prstDash val="solid"/>
           </a:ln>
@@ -7429,7 +7429,7 @@
             <a:r>
               <a:rPr lang="en-US" sz="1800" b="1" dirty="0">
                 <a:solidFill>
-                  <a:srgbClr val="26231E"/>
+                  <a:srgbClr val="38352F"/>
                 </a:solidFill>
                 <a:latin typeface="Bahnschrift" pitchFamily="34" charset="0"/>
                 <a:ea typeface="Bahnschrift" pitchFamily="34" charset="-122"/>
@@ -7468,7 +7468,7 @@
             <a:r>
               <a:rPr lang="en-US" sz="2200" b="1" dirty="0">
                 <a:solidFill>
-                  <a:srgbClr val="26231E"/>
+                  <a:srgbClr val="38352F"/>
                 </a:solidFill>
                 <a:latin typeface="Microsoft YaHei" pitchFamily="34" charset="0"/>
                 <a:ea typeface="Microsoft YaHei" pitchFamily="34" charset="-122"/>
@@ -7507,7 +7507,7 @@
             <a:r>
               <a:rPr lang="en-US" sz="1300" dirty="0">
                 <a:solidFill>
-                  <a:srgbClr val="6A6458"/>
+                  <a:srgbClr val="38352F"/>
                 </a:solidFill>
                 <a:latin typeface="Microsoft YaHei" pitchFamily="34" charset="0"/>
                 <a:ea typeface="Microsoft YaHei" pitchFamily="34" charset="-122"/>
@@ -7549,7 +7549,7 @@
             <a:lvl1pPr>
               <a:defRPr sz="1200">
                 <a:solidFill>
-                  <a:srgbClr val="26231E"/>
+                  <a:srgbClr val="38352F"/>
                 </a:solidFill>
                 <a:latin typeface="Bahnschrift"/>
                 <a:ea typeface="Bahnschrift"/>
@@ -7697,7 +7697,7 @@
             <a:r>
               <a:rPr lang="en-US" sz="1800" dirty="0">
                 <a:solidFill>
-                  <a:srgbClr val="ACA593"/>
+                  <a:srgbClr val="DAD7CE"/>
                 </a:solidFill>
                 <a:latin typeface="Microsoft YaHei" pitchFamily="34" charset="0"/>
                 <a:ea typeface="Microsoft YaHei" pitchFamily="34" charset="-122"/>
@@ -7736,7 +7736,7 @@
             <a:r>
               <a:rPr lang="en-US" sz="1200" dirty="0">
                 <a:solidFill>
-                  <a:srgbClr val="ACA593"/>
+                  <a:srgbClr val="DAD7CE"/>
                 </a:solidFill>
                 <a:latin typeface="Bahnschrift" pitchFamily="34" charset="0"/>
                 <a:ea typeface="Bahnschrift" pitchFamily="34" charset="-122"/>
@@ -7800,7 +7800,7 @@
             <a:r>
               <a:rPr lang="en-US" sz="2800" b="1" dirty="0">
                 <a:solidFill>
-                  <a:srgbClr val="26231E"/>
+                  <a:srgbClr val="38352F"/>
                 </a:solidFill>
                 <a:latin typeface="Microsoft YaHei" pitchFamily="34" charset="0"/>
                 <a:ea typeface="Microsoft YaHei" pitchFamily="34" charset="-122"/>
@@ -7829,11 +7829,11 @@
             </a:avLst>
           </a:prstGeom>
           <a:solidFill>
-            <a:srgbClr val="26231E"/>
+            <a:srgbClr val="38352F"/>
           </a:solidFill>
           <a:ln w="12700">
             <a:solidFill>
-              <a:srgbClr val="26231E"/>
+              <a:srgbClr val="38352F"/>
             </a:solidFill>
             <a:prstDash val="solid"/>
           </a:ln>
@@ -7907,11 +7907,11 @@
             <a:avLst/>
           </a:prstGeom>
           <a:solidFill>
-            <a:srgbClr val="26231E"/>
+            <a:srgbClr val="38352F"/>
           </a:solidFill>
           <a:ln w="12700">
             <a:solidFill>
-              <a:srgbClr val="26231E"/>
+              <a:srgbClr val="38352F"/>
             </a:solidFill>
             <a:prstDash val="solid"/>
           </a:ln>
@@ -7944,7 +7944,7 @@
             <a:r>
               <a:rPr lang="en-US" sz="1300" b="1" dirty="0">
                 <a:solidFill>
-                  <a:srgbClr val="26231E"/>
+                  <a:srgbClr val="38352F"/>
                 </a:solidFill>
                 <a:latin typeface="Bahnschrift" pitchFamily="34" charset="0"/>
                 <a:ea typeface="Bahnschrift" pitchFamily="34" charset="-122"/>
@@ -7983,7 +7983,7 @@
             <a:r>
               <a:rPr lang="en-US" sz="1300" b="1" dirty="0">
                 <a:solidFill>
-                  <a:srgbClr val="26231E"/>
+                  <a:srgbClr val="38352F"/>
                 </a:solidFill>
                 <a:latin typeface="Bahnschrift" pitchFamily="34" charset="0"/>
                 <a:ea typeface="Bahnschrift" pitchFamily="34" charset="-122"/>
@@ -8022,7 +8022,7 @@
             <a:r>
               <a:rPr lang="en-US" sz="1300" b="1" dirty="0">
                 <a:solidFill>
-                  <a:srgbClr val="26231E"/>
+                  <a:srgbClr val="38352F"/>
                 </a:solidFill>
                 <a:latin typeface="Bahnschrift" pitchFamily="34" charset="0"/>
                 <a:ea typeface="Bahnschrift" pitchFamily="34" charset="-122"/>
@@ -8061,7 +8061,7 @@
             <a:r>
               <a:rPr lang="en-US" sz="1300" b="1" dirty="0">
                 <a:solidFill>
-                  <a:srgbClr val="26231E"/>
+                  <a:srgbClr val="38352F"/>
                 </a:solidFill>
                 <a:latin typeface="Bahnschrift" pitchFamily="34" charset="0"/>
                 <a:ea typeface="Bahnschrift" pitchFamily="34" charset="-122"/>
@@ -8100,7 +8100,7 @@
             <a:r>
               <a:rPr lang="en-US" sz="1300" b="1" dirty="0">
                 <a:solidFill>
-                  <a:srgbClr val="26231E"/>
+                  <a:srgbClr val="38352F"/>
                 </a:solidFill>
                 <a:latin typeface="Bahnschrift" pitchFamily="34" charset="0"/>
                 <a:ea typeface="Bahnschrift" pitchFamily="34" charset="-122"/>
@@ -8139,7 +8139,7 @@
             <a:r>
               <a:rPr lang="en-US" sz="1300" b="1" dirty="0">
                 <a:solidFill>
-                  <a:srgbClr val="26231E"/>
+                  <a:srgbClr val="38352F"/>
                 </a:solidFill>
                 <a:latin typeface="Bahnschrift" pitchFamily="34" charset="0"/>
                 <a:ea typeface="Bahnschrift" pitchFamily="34" charset="-122"/>
@@ -8166,11 +8166,11 @@
             <a:avLst/>
           </a:prstGeom>
           <a:solidFill>
-            <a:srgbClr val="26231E"/>
+            <a:srgbClr val="38352F"/>
           </a:solidFill>
           <a:ln w="12700">
             <a:solidFill>
-              <a:srgbClr val="26231E"/>
+              <a:srgbClr val="38352F"/>
             </a:solidFill>
             <a:prstDash val="solid"/>
           </a:ln>
@@ -8318,7 +8318,7 @@
             <a:r>
               <a:rPr lang="en-US" sz="1500" dirty="0">
                 <a:solidFill>
-                  <a:srgbClr val="6A6458"/>
+                  <a:srgbClr val="38352F"/>
                 </a:solidFill>
                 <a:latin typeface="Microsoft YaHei" pitchFamily="34" charset="0"/>
                 <a:ea typeface="Microsoft YaHei" pitchFamily="34" charset="-122"/>
@@ -8347,11 +8347,11 @@
             </a:avLst>
           </a:prstGeom>
           <a:solidFill>
-            <a:srgbClr val="26231E"/>
+            <a:srgbClr val="38352F"/>
           </a:solidFill>
           <a:ln w="12700">
             <a:solidFill>
-              <a:srgbClr val="26231E"/>
+              <a:srgbClr val="38352F"/>
             </a:solidFill>
             <a:prstDash val="solid"/>
           </a:ln>
@@ -8409,7 +8409,7 @@
             <a:r>
               <a:rPr lang="en-US" sz="1500" dirty="0">
                 <a:solidFill>
-                  <a:srgbClr val="6A6458"/>
+                  <a:srgbClr val="38352F"/>
                 </a:solidFill>
                 <a:latin typeface="Microsoft YaHei" pitchFamily="34" charset="0"/>
                 <a:ea typeface="Microsoft YaHei" pitchFamily="34" charset="-122"/>
@@ -8438,11 +8438,11 @@
             </a:avLst>
           </a:prstGeom>
           <a:solidFill>
-            <a:srgbClr val="26231E"/>
+            <a:srgbClr val="38352F"/>
           </a:solidFill>
           <a:ln w="12700">
             <a:solidFill>
-              <a:srgbClr val="26231E"/>
+              <a:srgbClr val="38352F"/>
             </a:solidFill>
             <a:prstDash val="solid"/>
           </a:ln>
@@ -8500,7 +8500,7 @@
             <a:r>
               <a:rPr lang="en-US" sz="1500" dirty="0">
                 <a:solidFill>
-                  <a:srgbClr val="6A6458"/>
+                  <a:srgbClr val="38352F"/>
                 </a:solidFill>
                 <a:latin typeface="Microsoft YaHei" pitchFamily="34" charset="0"/>
                 <a:ea typeface="Microsoft YaHei" pitchFamily="34" charset="-122"/>
@@ -8529,11 +8529,11 @@
             </a:avLst>
           </a:prstGeom>
           <a:solidFill>
-            <a:srgbClr val="26231E"/>
+            <a:srgbClr val="38352F"/>
           </a:solidFill>
           <a:ln w="12700">
             <a:solidFill>
-              <a:srgbClr val="26231E"/>
+              <a:srgbClr val="38352F"/>
             </a:solidFill>
             <a:prstDash val="solid"/>
           </a:ln>
@@ -8591,7 +8591,7 @@
             <a:r>
               <a:rPr lang="en-US" sz="1500" dirty="0">
                 <a:solidFill>
-                  <a:srgbClr val="6A6458"/>
+                  <a:srgbClr val="38352F"/>
                 </a:solidFill>
                 <a:latin typeface="Microsoft YaHei" pitchFamily="34" charset="0"/>
                 <a:ea typeface="Microsoft YaHei" pitchFamily="34" charset="-122"/>
@@ -8620,11 +8620,11 @@
             </a:avLst>
           </a:prstGeom>
           <a:solidFill>
-            <a:srgbClr val="26231E"/>
+            <a:srgbClr val="38352F"/>
           </a:solidFill>
           <a:ln w="12700">
             <a:solidFill>
-              <a:srgbClr val="26231E"/>
+              <a:srgbClr val="38352F"/>
             </a:solidFill>
             <a:prstDash val="solid"/>
           </a:ln>
@@ -8685,7 +8685,7 @@
             <a:lvl1pPr>
               <a:defRPr sz="1200">
                 <a:solidFill>
-                  <a:srgbClr val="26231E"/>
+                  <a:srgbClr val="38352F"/>
                 </a:solidFill>
                 <a:latin typeface="Bahnschrift"/>
                 <a:ea typeface="Bahnschrift"/>
@@ -8755,7 +8755,7 @@
             <a:r>
               <a:rPr lang="en-US" sz="2800" b="1" dirty="0">
                 <a:solidFill>
-                  <a:srgbClr val="26231E"/>
+                  <a:srgbClr val="38352F"/>
                 </a:solidFill>
                 <a:latin typeface="Microsoft YaHei" pitchFamily="34" charset="0"/>
                 <a:ea typeface="Microsoft YaHei" pitchFamily="34" charset="-122"/>
@@ -8784,11 +8784,11 @@
             </a:avLst>
           </a:prstGeom>
           <a:solidFill>
-            <a:srgbClr val="26231E"/>
+            <a:srgbClr val="38352F"/>
           </a:solidFill>
           <a:ln w="12700">
             <a:solidFill>
-              <a:srgbClr val="26231E"/>
+              <a:srgbClr val="38352F"/>
             </a:solidFill>
             <a:prstDash val="solid"/>
           </a:ln>
@@ -8862,11 +8862,11 @@
             <a:avLst/>
           </a:prstGeom>
           <a:solidFill>
-            <a:srgbClr val="26231E"/>
+            <a:srgbClr val="38352F"/>
           </a:solidFill>
           <a:ln w="12700">
             <a:solidFill>
-              <a:srgbClr val="26231E"/>
+              <a:srgbClr val="38352F"/>
             </a:solidFill>
             <a:prstDash val="solid"/>
           </a:ln>
@@ -8899,7 +8899,7 @@
             <a:r>
               <a:rPr lang="en-US" sz="2000" b="1" dirty="0">
                 <a:solidFill>
-                  <a:srgbClr val="26231E"/>
+                  <a:srgbClr val="38352F"/>
                 </a:solidFill>
                 <a:latin typeface="Microsoft YaHei" pitchFamily="34" charset="0"/>
                 <a:ea typeface="Microsoft YaHei" pitchFamily="34" charset="-122"/>
@@ -8945,7 +8945,7 @@
             <a:r>
               <a:rPr lang="en-US" sz="1600" dirty="0">
                 <a:solidFill>
-                  <a:srgbClr val="26231E"/>
+                  <a:srgbClr val="38352F"/>
                 </a:solidFill>
                 <a:latin typeface="Microsoft YaHei" pitchFamily="34" charset="0"/>
                 <a:ea typeface="Microsoft YaHei" pitchFamily="34" charset="-122"/>
@@ -8969,7 +8969,7 @@
             <a:r>
               <a:rPr lang="en-US" sz="1600" dirty="0">
                 <a:solidFill>
-                  <a:srgbClr val="26231E"/>
+                  <a:srgbClr val="38352F"/>
                 </a:solidFill>
                 <a:latin typeface="Microsoft YaHei" pitchFamily="34" charset="0"/>
                 <a:ea typeface="Microsoft YaHei" pitchFamily="34" charset="-122"/>
@@ -8993,7 +8993,7 @@
             <a:r>
               <a:rPr lang="en-US" sz="1600" dirty="0">
                 <a:solidFill>
-                  <a:srgbClr val="26231E"/>
+                  <a:srgbClr val="38352F"/>
                 </a:solidFill>
                 <a:latin typeface="Microsoft YaHei" pitchFamily="34" charset="0"/>
                 <a:ea typeface="Microsoft YaHei" pitchFamily="34" charset="-122"/>
@@ -9020,11 +9020,11 @@
             <a:avLst/>
           </a:prstGeom>
           <a:solidFill>
-            <a:srgbClr val="26231E"/>
+            <a:srgbClr val="38352F"/>
           </a:solidFill>
           <a:ln w="12700">
             <a:solidFill>
-              <a:srgbClr val="26231E"/>
+              <a:srgbClr val="38352F"/>
             </a:solidFill>
             <a:prstDash val="solid"/>
           </a:ln>
@@ -9057,7 +9057,7 @@
             <a:r>
               <a:rPr lang="en-US" sz="2000" b="1" dirty="0">
                 <a:solidFill>
-                  <a:srgbClr val="26231E"/>
+                  <a:srgbClr val="38352F"/>
                 </a:solidFill>
                 <a:latin typeface="Microsoft YaHei" pitchFamily="34" charset="0"/>
                 <a:ea typeface="Microsoft YaHei" pitchFamily="34" charset="-122"/>
@@ -9103,7 +9103,7 @@
             <a:r>
               <a:rPr lang="en-US" sz="1600" dirty="0">
                 <a:solidFill>
-                  <a:srgbClr val="26231E"/>
+                  <a:srgbClr val="38352F"/>
                 </a:solidFill>
                 <a:latin typeface="Microsoft YaHei" pitchFamily="34" charset="0"/>
                 <a:ea typeface="Microsoft YaHei" pitchFamily="34" charset="-122"/>
@@ -9127,7 +9127,7 @@
             <a:r>
               <a:rPr lang="en-US" sz="1600" dirty="0">
                 <a:solidFill>
-                  <a:srgbClr val="26231E"/>
+                  <a:srgbClr val="38352F"/>
                 </a:solidFill>
                 <a:latin typeface="Microsoft YaHei" pitchFamily="34" charset="0"/>
                 <a:ea typeface="Microsoft YaHei" pitchFamily="34" charset="-122"/>
@@ -9151,7 +9151,7 @@
             <a:r>
               <a:rPr lang="en-US" sz="1600" dirty="0">
                 <a:solidFill>
-                  <a:srgbClr val="26231E"/>
+                  <a:srgbClr val="38352F"/>
                 </a:solidFill>
                 <a:latin typeface="Microsoft YaHei" pitchFamily="34" charset="0"/>
                 <a:ea typeface="Microsoft YaHei" pitchFamily="34" charset="-122"/>
@@ -9193,7 +9193,7 @@
             <a:lvl1pPr>
               <a:defRPr sz="1200">
                 <a:solidFill>
-                  <a:srgbClr val="26231E"/>
+                  <a:srgbClr val="38352F"/>
                 </a:solidFill>
                 <a:latin typeface="Bahnschrift"/>
                 <a:ea typeface="Bahnschrift"/>
@@ -9263,7 +9263,7 @@
             <a:r>
               <a:rPr lang="en-US" sz="2800" b="1" dirty="0">
                 <a:solidFill>
-                  <a:srgbClr val="26231E"/>
+                  <a:srgbClr val="38352F"/>
                 </a:solidFill>
                 <a:latin typeface="Microsoft YaHei" pitchFamily="34" charset="0"/>
                 <a:ea typeface="Microsoft YaHei" pitchFamily="34" charset="-122"/>
@@ -9292,11 +9292,11 @@
             </a:avLst>
           </a:prstGeom>
           <a:solidFill>
-            <a:srgbClr val="26231E"/>
+            <a:srgbClr val="38352F"/>
           </a:solidFill>
           <a:ln w="12700">
             <a:solidFill>
-              <a:srgbClr val="26231E"/>
+              <a:srgbClr val="38352F"/>
             </a:solidFill>
             <a:prstDash val="solid"/>
           </a:ln>
@@ -9395,7 +9395,7 @@
                       <a:r>
                         <a:rPr lang="en-US" sz="1300" b="1" dirty="0">
                           <a:solidFill>
-                            <a:srgbClr val="26231E"/>
+                            <a:srgbClr val="38352F"/>
                           </a:solidFill>
                           <a:latin typeface="Microsoft YaHei" pitchFamily="34" charset="0"/>
                           <a:ea typeface="Microsoft YaHei" pitchFamily="34" charset="-122"/>
@@ -9419,7 +9419,7 @@
                     </a:lnR>
                     <a:lnT w="28575" cap="flat" cmpd="sng" algn="ctr">
                       <a:solidFill>
-                        <a:srgbClr val="26231E"/>
+                        <a:srgbClr val="38352F"/>
                       </a:solidFill>
                       <a:prstDash val="solid"/>
                       <a:round/>
@@ -9428,7 +9428,7 @@
                     </a:lnT>
                     <a:lnB w="9525" cap="flat" cmpd="sng" algn="ctr">
                       <a:solidFill>
-                        <a:srgbClr val="26231E"/>
+                        <a:srgbClr val="38352F"/>
                       </a:solidFill>
                       <a:prstDash val="solid"/>
                       <a:round/>
@@ -9448,7 +9448,7 @@
                       <a:r>
                         <a:rPr lang="en-US" sz="1300" b="1" dirty="0">
                           <a:solidFill>
-                            <a:srgbClr val="26231E"/>
+                            <a:srgbClr val="38352F"/>
                           </a:solidFill>
                           <a:latin typeface="Microsoft YaHei" pitchFamily="34" charset="0"/>
                           <a:ea typeface="Microsoft YaHei" pitchFamily="34" charset="-122"/>
@@ -9472,7 +9472,7 @@
                     </a:lnR>
                     <a:lnT w="28575" cap="flat" cmpd="sng" algn="ctr">
                       <a:solidFill>
-                        <a:srgbClr val="26231E"/>
+                        <a:srgbClr val="38352F"/>
                       </a:solidFill>
                       <a:prstDash val="solid"/>
                       <a:round/>
@@ -9481,7 +9481,7 @@
                     </a:lnT>
                     <a:lnB w="9525" cap="flat" cmpd="sng" algn="ctr">
                       <a:solidFill>
-                        <a:srgbClr val="26231E"/>
+                        <a:srgbClr val="38352F"/>
                       </a:solidFill>
                       <a:prstDash val="solid"/>
                       <a:round/>
@@ -9501,7 +9501,7 @@
                       <a:r>
                         <a:rPr lang="en-US" sz="1300" b="1" dirty="0">
                           <a:solidFill>
-                            <a:srgbClr val="26231E"/>
+                            <a:srgbClr val="38352F"/>
                           </a:solidFill>
                           <a:latin typeface="Microsoft YaHei" pitchFamily="34" charset="0"/>
                           <a:ea typeface="Microsoft YaHei" pitchFamily="34" charset="-122"/>
@@ -9525,7 +9525,7 @@
                     </a:lnR>
                     <a:lnT w="28575" cap="flat" cmpd="sng" algn="ctr">
                       <a:solidFill>
-                        <a:srgbClr val="26231E"/>
+                        <a:srgbClr val="38352F"/>
                       </a:solidFill>
                       <a:prstDash val="solid"/>
                       <a:round/>
@@ -9534,7 +9534,7 @@
                     </a:lnT>
                     <a:lnB w="9525" cap="flat" cmpd="sng" algn="ctr">
                       <a:solidFill>
-                        <a:srgbClr val="26231E"/>
+                        <a:srgbClr val="38352F"/>
                       </a:solidFill>
                       <a:prstDash val="solid"/>
                       <a:round/>
@@ -9554,7 +9554,7 @@
                       <a:r>
                         <a:rPr lang="en-US" sz="1300" b="1" dirty="0">
                           <a:solidFill>
-                            <a:srgbClr val="26231E"/>
+                            <a:srgbClr val="38352F"/>
                           </a:solidFill>
                           <a:latin typeface="Microsoft YaHei" pitchFamily="34" charset="0"/>
                           <a:ea typeface="Microsoft YaHei" pitchFamily="34" charset="-122"/>
@@ -9578,7 +9578,7 @@
                     </a:lnR>
                     <a:lnT w="28575" cap="flat" cmpd="sng" algn="ctr">
                       <a:solidFill>
-                        <a:srgbClr val="26231E"/>
+                        <a:srgbClr val="38352F"/>
                       </a:solidFill>
                       <a:prstDash val="solid"/>
                       <a:round/>
@@ -9587,7 +9587,7 @@
                     </a:lnT>
                     <a:lnB w="9525" cap="flat" cmpd="sng" algn="ctr">
                       <a:solidFill>
-                        <a:srgbClr val="26231E"/>
+                        <a:srgbClr val="38352F"/>
                       </a:solidFill>
                       <a:prstDash val="solid"/>
                       <a:round/>
@@ -9609,7 +9609,7 @@
                       <a:r>
                         <a:rPr lang="en-US" sz="1400" dirty="0">
                           <a:solidFill>
-                            <a:srgbClr val="6A6458"/>
+                            <a:srgbClr val="38352F"/>
                           </a:solidFill>
                           <a:latin typeface="Microsoft YaHei" pitchFamily="34" charset="0"/>
                           <a:ea typeface="Microsoft YaHei" pitchFamily="34" charset="-122"/>
@@ -9656,7 +9656,7 @@
                       <a:r>
                         <a:rPr lang="en-US" sz="1400" dirty="0">
                           <a:solidFill>
-                            <a:srgbClr val="6A6458"/>
+                            <a:srgbClr val="38352F"/>
                           </a:solidFill>
                           <a:latin typeface="Microsoft YaHei" pitchFamily="34" charset="0"/>
                           <a:ea typeface="Microsoft YaHei" pitchFamily="34" charset="-122"/>
@@ -9703,7 +9703,7 @@
                       <a:r>
                         <a:rPr lang="en-US" sz="1400" dirty="0">
                           <a:solidFill>
-                            <a:srgbClr val="6A6458"/>
+                            <a:srgbClr val="38352F"/>
                           </a:solidFill>
                           <a:latin typeface="Microsoft YaHei" pitchFamily="34" charset="0"/>
                           <a:ea typeface="Microsoft YaHei" pitchFamily="34" charset="-122"/>
@@ -9750,7 +9750,7 @@
                       <a:r>
                         <a:rPr lang="en-US" sz="1400" dirty="0">
                           <a:solidFill>
-                            <a:srgbClr val="6A6458"/>
+                            <a:srgbClr val="38352F"/>
                           </a:solidFill>
                           <a:latin typeface="Microsoft YaHei" pitchFamily="34" charset="0"/>
                           <a:ea typeface="Microsoft YaHei" pitchFamily="34" charset="-122"/>
@@ -9799,7 +9799,7 @@
                       <a:r>
                         <a:rPr lang="en-US" sz="1400" dirty="0">
                           <a:solidFill>
-                            <a:srgbClr val="6A6458"/>
+                            <a:srgbClr val="38352F"/>
                           </a:solidFill>
                           <a:latin typeface="Microsoft YaHei" pitchFamily="34" charset="0"/>
                           <a:ea typeface="Microsoft YaHei" pitchFamily="34" charset="-122"/>
@@ -9846,7 +9846,7 @@
                       <a:r>
                         <a:rPr lang="en-US" sz="1400" dirty="0">
                           <a:solidFill>
-                            <a:srgbClr val="6A6458"/>
+                            <a:srgbClr val="38352F"/>
                           </a:solidFill>
                           <a:latin typeface="Microsoft YaHei" pitchFamily="34" charset="0"/>
                           <a:ea typeface="Microsoft YaHei" pitchFamily="34" charset="-122"/>
@@ -9893,7 +9893,7 @@
                       <a:r>
                         <a:rPr lang="en-US" sz="1400" dirty="0">
                           <a:solidFill>
-                            <a:srgbClr val="6A6458"/>
+                            <a:srgbClr val="38352F"/>
                           </a:solidFill>
                           <a:latin typeface="Microsoft YaHei" pitchFamily="34" charset="0"/>
                           <a:ea typeface="Microsoft YaHei" pitchFamily="34" charset="-122"/>
@@ -9940,7 +9940,7 @@
                       <a:r>
                         <a:rPr lang="en-US" sz="1400" dirty="0">
                           <a:solidFill>
-                            <a:srgbClr val="6A6458"/>
+                            <a:srgbClr val="38352F"/>
                           </a:solidFill>
                           <a:latin typeface="Microsoft YaHei" pitchFamily="34" charset="0"/>
                           <a:ea typeface="Microsoft YaHei" pitchFamily="34" charset="-122"/>
@@ -9989,7 +9989,7 @@
                       <a:r>
                         <a:rPr lang="en-US" sz="1400" dirty="0">
                           <a:solidFill>
-                            <a:srgbClr val="6A6458"/>
+                            <a:srgbClr val="38352F"/>
                           </a:solidFill>
                           <a:latin typeface="Microsoft YaHei" pitchFamily="34" charset="0"/>
                           <a:ea typeface="Microsoft YaHei" pitchFamily="34" charset="-122"/>
@@ -10016,7 +10016,7 @@
                     </a:lnT>
                     <a:lnB w="12700" cap="flat" cmpd="sng" algn="ctr">
                       <a:solidFill>
-                        <a:srgbClr val="26231E"/>
+                        <a:srgbClr val="38352F"/>
                       </a:solidFill>
                       <a:prstDash val="solid"/>
                       <a:round/>
@@ -10036,7 +10036,7 @@
                       <a:r>
                         <a:rPr lang="en-US" sz="1400" dirty="0">
                           <a:solidFill>
-                            <a:srgbClr val="6A6458"/>
+                            <a:srgbClr val="38352F"/>
                           </a:solidFill>
                           <a:latin typeface="Microsoft YaHei" pitchFamily="34" charset="0"/>
                           <a:ea typeface="Microsoft YaHei" pitchFamily="34" charset="-122"/>
@@ -10063,7 +10063,7 @@
                     </a:lnT>
                     <a:lnB w="12700" cap="flat" cmpd="sng" algn="ctr">
                       <a:solidFill>
-                        <a:srgbClr val="26231E"/>
+                        <a:srgbClr val="38352F"/>
                       </a:solidFill>
                       <a:prstDash val="solid"/>
                       <a:round/>
@@ -10083,7 +10083,7 @@
                       <a:r>
                         <a:rPr lang="en-US" sz="1400" dirty="0">
                           <a:solidFill>
-                            <a:srgbClr val="6A6458"/>
+                            <a:srgbClr val="38352F"/>
                           </a:solidFill>
                           <a:latin typeface="Microsoft YaHei" pitchFamily="34" charset="0"/>
                           <a:ea typeface="Microsoft YaHei" pitchFamily="34" charset="-122"/>
@@ -10110,7 +10110,7 @@
                     </a:lnT>
                     <a:lnB w="12700" cap="flat" cmpd="sng" algn="ctr">
                       <a:solidFill>
-                        <a:srgbClr val="26231E"/>
+                        <a:srgbClr val="38352F"/>
                       </a:solidFill>
                       <a:prstDash val="solid"/>
                       <a:round/>
@@ -10130,7 +10130,7 @@
                       <a:r>
                         <a:rPr lang="en-US" sz="1400" dirty="0">
                           <a:solidFill>
-                            <a:srgbClr val="6A6458"/>
+                            <a:srgbClr val="38352F"/>
                           </a:solidFill>
                           <a:latin typeface="Microsoft YaHei" pitchFamily="34" charset="0"/>
                           <a:ea typeface="Microsoft YaHei" pitchFamily="34" charset="-122"/>
@@ -10157,7 +10157,7 @@
                     </a:lnT>
                     <a:lnB w="12700" cap="flat" cmpd="sng" algn="ctr">
                       <a:solidFill>
-                        <a:srgbClr val="26231E"/>
+                        <a:srgbClr val="38352F"/>
                       </a:solidFill>
                       <a:prstDash val="solid"/>
                       <a:round/>
@@ -10201,7 +10201,7 @@
             <a:lvl1pPr>
               <a:defRPr sz="1200">
                 <a:solidFill>
-                  <a:srgbClr val="26231E"/>
+                  <a:srgbClr val="38352F"/>
                 </a:solidFill>
                 <a:latin typeface="Bahnschrift"/>
                 <a:ea typeface="Bahnschrift"/>
@@ -10271,7 +10271,7 @@
             <a:r>
               <a:rPr lang="en-US" sz="2800" b="1" dirty="0">
                 <a:solidFill>
-                  <a:srgbClr val="26231E"/>
+                  <a:srgbClr val="38352F"/>
                 </a:solidFill>
                 <a:latin typeface="Microsoft YaHei" pitchFamily="34" charset="0"/>
                 <a:ea typeface="Microsoft YaHei" pitchFamily="34" charset="-122"/>
@@ -10300,11 +10300,11 @@
             </a:avLst>
           </a:prstGeom>
           <a:solidFill>
-            <a:srgbClr val="26231E"/>
+            <a:srgbClr val="38352F"/>
           </a:solidFill>
           <a:ln w="12700">
             <a:solidFill>
-              <a:srgbClr val="26231E"/>
+              <a:srgbClr val="38352F"/>
             </a:solidFill>
             <a:prstDash val="solid"/>
           </a:ln>
@@ -10415,7 +10415,7 @@
             <a:r>
               <a:rPr lang="en-US" sz="2200" b="1" dirty="0">
                 <a:solidFill>
-                  <a:srgbClr val="26231E"/>
+                  <a:srgbClr val="38352F"/>
                 </a:solidFill>
                 <a:latin typeface="Microsoft YaHei" pitchFamily="34" charset="0"/>
                 <a:ea typeface="Microsoft YaHei" pitchFamily="34" charset="-122"/>
@@ -10454,7 +10454,7 @@
             <a:r>
               <a:rPr lang="en-US" sz="1400" dirty="0">
                 <a:solidFill>
-                  <a:srgbClr val="6A6458"/>
+                  <a:srgbClr val="38352F"/>
                 </a:solidFill>
                 <a:latin typeface="Microsoft YaHei" pitchFamily="34" charset="0"/>
                 <a:ea typeface="Microsoft YaHei" pitchFamily="34" charset="-122"/>
@@ -10557,7 +10557,7 @@
             <a:r>
               <a:rPr lang="en-US" sz="2200" b="1" dirty="0">
                 <a:solidFill>
-                  <a:srgbClr val="26231E"/>
+                  <a:srgbClr val="38352F"/>
                 </a:solidFill>
                 <a:latin typeface="Microsoft YaHei" pitchFamily="34" charset="0"/>
                 <a:ea typeface="Microsoft YaHei" pitchFamily="34" charset="-122"/>
@@ -10596,7 +10596,7 @@
             <a:r>
               <a:rPr lang="en-US" sz="1400" dirty="0">
                 <a:solidFill>
-                  <a:srgbClr val="6A6458"/>
+                  <a:srgbClr val="38352F"/>
                 </a:solidFill>
                 <a:latin typeface="Microsoft YaHei" pitchFamily="34" charset="0"/>
                 <a:ea typeface="Microsoft YaHei" pitchFamily="34" charset="-122"/>
@@ -10699,7 +10699,7 @@
             <a:r>
               <a:rPr lang="en-US" sz="2200" b="1" dirty="0">
                 <a:solidFill>
-                  <a:srgbClr val="26231E"/>
+                  <a:srgbClr val="38352F"/>
                 </a:solidFill>
                 <a:latin typeface="Microsoft YaHei" pitchFamily="34" charset="0"/>
                 <a:ea typeface="Microsoft YaHei" pitchFamily="34" charset="-122"/>
@@ -10738,7 +10738,7 @@
             <a:r>
               <a:rPr lang="en-US" sz="1400" dirty="0">
                 <a:solidFill>
-                  <a:srgbClr val="6A6458"/>
+                  <a:srgbClr val="38352F"/>
                 </a:solidFill>
                 <a:latin typeface="Microsoft YaHei" pitchFamily="34" charset="0"/>
                 <a:ea typeface="Microsoft YaHei" pitchFamily="34" charset="-122"/>
@@ -10841,7 +10841,7 @@
             <a:r>
               <a:rPr lang="en-US" sz="2200" b="1" dirty="0">
                 <a:solidFill>
-                  <a:srgbClr val="26231E"/>
+                  <a:srgbClr val="38352F"/>
                 </a:solidFill>
                 <a:latin typeface="Microsoft YaHei" pitchFamily="34" charset="0"/>
                 <a:ea typeface="Microsoft YaHei" pitchFamily="34" charset="-122"/>
@@ -10880,7 +10880,7 @@
             <a:r>
               <a:rPr lang="en-US" sz="1400" dirty="0">
                 <a:solidFill>
-                  <a:srgbClr val="6A6458"/>
+                  <a:srgbClr val="38352F"/>
                 </a:solidFill>
                 <a:latin typeface="Microsoft YaHei" pitchFamily="34" charset="0"/>
                 <a:ea typeface="Microsoft YaHei" pitchFamily="34" charset="-122"/>
@@ -10983,7 +10983,7 @@
             <a:r>
               <a:rPr lang="en-US" sz="2200" b="1" dirty="0">
                 <a:solidFill>
-                  <a:srgbClr val="26231E"/>
+                  <a:srgbClr val="38352F"/>
                 </a:solidFill>
                 <a:latin typeface="Microsoft YaHei" pitchFamily="34" charset="0"/>
                 <a:ea typeface="Microsoft YaHei" pitchFamily="34" charset="-122"/>
@@ -11022,7 +11022,7 @@
             <a:r>
               <a:rPr lang="en-US" sz="1400" dirty="0">
                 <a:solidFill>
-                  <a:srgbClr val="6A6458"/>
+                  <a:srgbClr val="38352F"/>
                 </a:solidFill>
                 <a:latin typeface="Microsoft YaHei" pitchFamily="34" charset="0"/>
                 <a:ea typeface="Microsoft YaHei" pitchFamily="34" charset="-122"/>
@@ -11049,11 +11049,11 @@
             <a:avLst/>
           </a:prstGeom>
           <a:solidFill>
-            <a:srgbClr val="26231E"/>
+            <a:srgbClr val="38352F"/>
           </a:solidFill>
           <a:ln w="12700">
             <a:solidFill>
-              <a:srgbClr val="26231E"/>
+              <a:srgbClr val="38352F"/>
             </a:solidFill>
             <a:prstDash val="solid"/>
           </a:ln>
@@ -11089,7 +11089,7 @@
             <a:lvl1pPr>
               <a:defRPr sz="1200">
                 <a:solidFill>
-                  <a:srgbClr val="26231E"/>
+                  <a:srgbClr val="38352F"/>
                 </a:solidFill>
                 <a:latin typeface="Bahnschrift"/>
                 <a:ea typeface="Bahnschrift"/>
@@ -11159,7 +11159,7 @@
             <a:r>
               <a:rPr lang="en-US" sz="2800" b="1" dirty="0">
                 <a:solidFill>
-                  <a:srgbClr val="26231E"/>
+                  <a:srgbClr val="38352F"/>
                 </a:solidFill>
                 <a:latin typeface="Microsoft YaHei" pitchFamily="34" charset="0"/>
                 <a:ea typeface="Microsoft YaHei" pitchFamily="34" charset="-122"/>
@@ -11188,11 +11188,11 @@
             </a:avLst>
           </a:prstGeom>
           <a:solidFill>
-            <a:srgbClr val="26231E"/>
+            <a:srgbClr val="38352F"/>
           </a:solidFill>
           <a:ln w="12700">
             <a:solidFill>
-              <a:srgbClr val="26231E"/>
+              <a:srgbClr val="38352F"/>
             </a:solidFill>
             <a:prstDash val="solid"/>
           </a:ln>
@@ -11266,11 +11266,11 @@
             <a:avLst/>
           </a:prstGeom>
           <a:solidFill>
-            <a:srgbClr val="26231E"/>
+            <a:srgbClr val="38352F"/>
           </a:solidFill>
           <a:ln w="12700">
             <a:solidFill>
-              <a:srgbClr val="26231E"/>
+              <a:srgbClr val="38352F"/>
             </a:solidFill>
             <a:prstDash val="solid"/>
           </a:ln>
@@ -11303,7 +11303,7 @@
             <a:r>
               <a:rPr lang="en-US" sz="1600" b="1" dirty="0">
                 <a:solidFill>
-                  <a:srgbClr val="26231E"/>
+                  <a:srgbClr val="38352F"/>
                 </a:solidFill>
                 <a:latin typeface="Bahnschrift" pitchFamily="34" charset="0"/>
                 <a:ea typeface="Bahnschrift" pitchFamily="34" charset="-122"/>
@@ -11342,7 +11342,7 @@
             <a:r>
               <a:rPr lang="en-US" sz="1800" b="1" dirty="0">
                 <a:solidFill>
-                  <a:srgbClr val="26231E"/>
+                  <a:srgbClr val="38352F"/>
                 </a:solidFill>
                 <a:latin typeface="Microsoft YaHei" pitchFamily="34" charset="0"/>
                 <a:ea typeface="Microsoft YaHei" pitchFamily="34" charset="-122"/>
@@ -11384,7 +11384,7 @@
             <a:r>
               <a:rPr lang="en-US" sz="1300" dirty="0">
                 <a:solidFill>
-                  <a:srgbClr val="6A6458"/>
+                  <a:srgbClr val="38352F"/>
                 </a:solidFill>
                 <a:latin typeface="Microsoft YaHei" pitchFamily="34" charset="0"/>
                 <a:ea typeface="Microsoft YaHei" pitchFamily="34" charset="-122"/>
@@ -11411,11 +11411,11 @@
             <a:avLst/>
           </a:prstGeom>
           <a:solidFill>
-            <a:srgbClr val="26231E"/>
+            <a:srgbClr val="38352F"/>
           </a:solidFill>
           <a:ln w="12700">
             <a:solidFill>
-              <a:srgbClr val="26231E"/>
+              <a:srgbClr val="38352F"/>
             </a:solidFill>
             <a:prstDash val="solid"/>
           </a:ln>
@@ -11448,7 +11448,7 @@
             <a:r>
               <a:rPr lang="en-US" sz="1600" b="1" dirty="0">
                 <a:solidFill>
-                  <a:srgbClr val="26231E"/>
+                  <a:srgbClr val="38352F"/>
                 </a:solidFill>
                 <a:latin typeface="Bahnschrift" pitchFamily="34" charset="0"/>
                 <a:ea typeface="Bahnschrift" pitchFamily="34" charset="-122"/>
@@ -11487,7 +11487,7 @@
             <a:r>
               <a:rPr lang="en-US" sz="1800" b="1" dirty="0">
                 <a:solidFill>
-                  <a:srgbClr val="26231E"/>
+                  <a:srgbClr val="38352F"/>
                 </a:solidFill>
                 <a:latin typeface="Microsoft YaHei" pitchFamily="34" charset="0"/>
                 <a:ea typeface="Microsoft YaHei" pitchFamily="34" charset="-122"/>
@@ -11529,7 +11529,7 @@
             <a:r>
               <a:rPr lang="en-US" sz="1300" dirty="0">
                 <a:solidFill>
-                  <a:srgbClr val="6A6458"/>
+                  <a:srgbClr val="38352F"/>
                 </a:solidFill>
                 <a:latin typeface="Microsoft YaHei" pitchFamily="34" charset="0"/>
                 <a:ea typeface="Microsoft YaHei" pitchFamily="34" charset="-122"/>
@@ -11556,11 +11556,11 @@
             <a:avLst/>
           </a:prstGeom>
           <a:solidFill>
-            <a:srgbClr val="26231E"/>
+            <a:srgbClr val="38352F"/>
           </a:solidFill>
           <a:ln w="12700">
             <a:solidFill>
-              <a:srgbClr val="26231E"/>
+              <a:srgbClr val="38352F"/>
             </a:solidFill>
             <a:prstDash val="solid"/>
           </a:ln>
@@ -11593,7 +11593,7 @@
             <a:r>
               <a:rPr lang="en-US" sz="1600" b="1" dirty="0">
                 <a:solidFill>
-                  <a:srgbClr val="26231E"/>
+                  <a:srgbClr val="38352F"/>
                 </a:solidFill>
                 <a:latin typeface="Bahnschrift" pitchFamily="34" charset="0"/>
                 <a:ea typeface="Bahnschrift" pitchFamily="34" charset="-122"/>
@@ -11632,7 +11632,7 @@
             <a:r>
               <a:rPr lang="en-US" sz="1800" b="1" dirty="0">
                 <a:solidFill>
-                  <a:srgbClr val="26231E"/>
+                  <a:srgbClr val="38352F"/>
                 </a:solidFill>
                 <a:latin typeface="Microsoft YaHei" pitchFamily="34" charset="0"/>
                 <a:ea typeface="Microsoft YaHei" pitchFamily="34" charset="-122"/>
@@ -11674,7 +11674,7 @@
             <a:r>
               <a:rPr lang="en-US" sz="1300" dirty="0">
                 <a:solidFill>
-                  <a:srgbClr val="6A6458"/>
+                  <a:srgbClr val="38352F"/>
                 </a:solidFill>
                 <a:latin typeface="Microsoft YaHei" pitchFamily="34" charset="0"/>
                 <a:ea typeface="Microsoft YaHei" pitchFamily="34" charset="-122"/>
@@ -11716,7 +11716,7 @@
             <a:lvl1pPr>
               <a:defRPr sz="1200">
                 <a:solidFill>
-                  <a:srgbClr val="26231E"/>
+                  <a:srgbClr val="38352F"/>
                 </a:solidFill>
                 <a:latin typeface="Bahnschrift"/>
                 <a:ea typeface="Bahnschrift"/>
@@ -11864,7 +11864,7 @@
             <a:r>
               <a:rPr lang="en-US" sz="1800" dirty="0">
                 <a:solidFill>
-                  <a:srgbClr val="ACA593"/>
+                  <a:srgbClr val="DAD7CE"/>
                 </a:solidFill>
                 <a:latin typeface="Microsoft YaHei" pitchFamily="34" charset="0"/>
                 <a:ea typeface="Microsoft YaHei" pitchFamily="34" charset="-122"/>
@@ -11903,7 +11903,7 @@
             <a:r>
               <a:rPr lang="en-US" sz="1200" dirty="0">
                 <a:solidFill>
-                  <a:srgbClr val="ACA593"/>
+                  <a:srgbClr val="DAD7CE"/>
                 </a:solidFill>
                 <a:latin typeface="Bahnschrift" pitchFamily="34" charset="0"/>
                 <a:ea typeface="Bahnschrift" pitchFamily="34" charset="-122"/>
@@ -11967,7 +11967,7 @@
             <a:r>
               <a:rPr lang="en-US" sz="2800" b="1" dirty="0">
                 <a:solidFill>
-                  <a:srgbClr val="26231E"/>
+                  <a:srgbClr val="38352F"/>
                 </a:solidFill>
                 <a:latin typeface="Microsoft YaHei" pitchFamily="34" charset="0"/>
                 <a:ea typeface="Microsoft YaHei" pitchFamily="34" charset="-122"/>
@@ -11996,11 +11996,11 @@
             </a:avLst>
           </a:prstGeom>
           <a:solidFill>
-            <a:srgbClr val="26231E"/>
+            <a:srgbClr val="38352F"/>
           </a:solidFill>
           <a:ln w="12700">
             <a:solidFill>
-              <a:srgbClr val="26231E"/>
+              <a:srgbClr val="38352F"/>
             </a:solidFill>
             <a:prstDash val="solid"/>
           </a:ln>
@@ -12086,7 +12086,7 @@
             <a:r>
               <a:rPr lang="en-US" sz="3200" b="1" dirty="0">
                 <a:solidFill>
-                  <a:srgbClr val="26231E"/>
+                  <a:srgbClr val="38352F"/>
                 </a:solidFill>
                 <a:latin typeface="Microsoft YaHei" pitchFamily="34" charset="0"/>
                 <a:ea typeface="Microsoft YaHei" pitchFamily="34" charset="-122"/>
@@ -12113,11 +12113,11 @@
             <a:avLst/>
           </a:prstGeom>
           <a:solidFill>
-            <a:srgbClr val="26231E"/>
+            <a:srgbClr val="38352F"/>
           </a:solidFill>
           <a:ln w="12700">
             <a:solidFill>
-              <a:srgbClr val="26231E"/>
+              <a:srgbClr val="38352F"/>
             </a:solidFill>
             <a:prstDash val="solid"/>
           </a:ln>
@@ -12150,7 +12150,7 @@
             <a:r>
               <a:rPr lang="en-US" sz="1600" b="1" dirty="0">
                 <a:solidFill>
-                  <a:srgbClr val="26231E"/>
+                  <a:srgbClr val="38352F"/>
                 </a:solidFill>
                 <a:latin typeface="Bahnschrift" pitchFamily="34" charset="0"/>
                 <a:ea typeface="Bahnschrift" pitchFamily="34" charset="-122"/>
@@ -12189,7 +12189,7 @@
             <a:r>
               <a:rPr lang="en-US" sz="1800" b="1" dirty="0">
                 <a:solidFill>
-                  <a:srgbClr val="26231E"/>
+                  <a:srgbClr val="38352F"/>
                 </a:solidFill>
                 <a:latin typeface="Microsoft YaHei" pitchFamily="34" charset="0"/>
                 <a:ea typeface="Microsoft YaHei" pitchFamily="34" charset="-122"/>
@@ -12231,7 +12231,7 @@
             <a:r>
               <a:rPr lang="en-US" sz="1300" dirty="0">
                 <a:solidFill>
-                  <a:srgbClr val="6A6458"/>
+                  <a:srgbClr val="38352F"/>
                 </a:solidFill>
                 <a:latin typeface="Microsoft YaHei" pitchFamily="34" charset="0"/>
                 <a:ea typeface="Microsoft YaHei" pitchFamily="34" charset="-122"/>
@@ -12258,11 +12258,11 @@
             <a:avLst/>
           </a:prstGeom>
           <a:solidFill>
-            <a:srgbClr val="26231E"/>
+            <a:srgbClr val="38352F"/>
           </a:solidFill>
           <a:ln w="12700">
             <a:solidFill>
-              <a:srgbClr val="26231E"/>
+              <a:srgbClr val="38352F"/>
             </a:solidFill>
             <a:prstDash val="solid"/>
           </a:ln>
@@ -12295,7 +12295,7 @@
             <a:r>
               <a:rPr lang="en-US" sz="1600" b="1" dirty="0">
                 <a:solidFill>
-                  <a:srgbClr val="26231E"/>
+                  <a:srgbClr val="38352F"/>
                 </a:solidFill>
                 <a:latin typeface="Bahnschrift" pitchFamily="34" charset="0"/>
                 <a:ea typeface="Bahnschrift" pitchFamily="34" charset="-122"/>
@@ -12334,7 +12334,7 @@
             <a:r>
               <a:rPr lang="en-US" sz="1800" b="1" dirty="0">
                 <a:solidFill>
-                  <a:srgbClr val="26231E"/>
+                  <a:srgbClr val="38352F"/>
                 </a:solidFill>
                 <a:latin typeface="Microsoft YaHei" pitchFamily="34" charset="0"/>
                 <a:ea typeface="Microsoft YaHei" pitchFamily="34" charset="-122"/>
@@ -12376,7 +12376,7 @@
             <a:r>
               <a:rPr lang="en-US" sz="1300" dirty="0">
                 <a:solidFill>
-                  <a:srgbClr val="6A6458"/>
+                  <a:srgbClr val="38352F"/>
                 </a:solidFill>
                 <a:latin typeface="Microsoft YaHei" pitchFamily="34" charset="0"/>
                 <a:ea typeface="Microsoft YaHei" pitchFamily="34" charset="-122"/>
@@ -12403,11 +12403,11 @@
             <a:avLst/>
           </a:prstGeom>
           <a:solidFill>
-            <a:srgbClr val="26231E"/>
+            <a:srgbClr val="38352F"/>
           </a:solidFill>
           <a:ln w="12700">
             <a:solidFill>
-              <a:srgbClr val="26231E"/>
+              <a:srgbClr val="38352F"/>
             </a:solidFill>
             <a:prstDash val="solid"/>
           </a:ln>
@@ -12440,7 +12440,7 @@
             <a:r>
               <a:rPr lang="en-US" sz="1600" b="1" dirty="0">
                 <a:solidFill>
-                  <a:srgbClr val="26231E"/>
+                  <a:srgbClr val="38352F"/>
                 </a:solidFill>
                 <a:latin typeface="Bahnschrift" pitchFamily="34" charset="0"/>
                 <a:ea typeface="Bahnschrift" pitchFamily="34" charset="-122"/>
@@ -12479,7 +12479,7 @@
             <a:r>
               <a:rPr lang="en-US" sz="1800" b="1" dirty="0">
                 <a:solidFill>
-                  <a:srgbClr val="26231E"/>
+                  <a:srgbClr val="38352F"/>
                 </a:solidFill>
                 <a:latin typeface="Microsoft YaHei" pitchFamily="34" charset="0"/>
                 <a:ea typeface="Microsoft YaHei" pitchFamily="34" charset="-122"/>
@@ -12521,7 +12521,7 @@
             <a:r>
               <a:rPr lang="en-US" sz="1300" dirty="0">
                 <a:solidFill>
-                  <a:srgbClr val="6A6458"/>
+                  <a:srgbClr val="38352F"/>
                 </a:solidFill>
                 <a:latin typeface="Microsoft YaHei" pitchFamily="34" charset="0"/>
                 <a:ea typeface="Microsoft YaHei" pitchFamily="34" charset="-122"/>
@@ -12563,7 +12563,7 @@
             <a:lvl1pPr>
               <a:defRPr sz="1200">
                 <a:solidFill>
-                  <a:srgbClr val="26231E"/>
+                  <a:srgbClr val="38352F"/>
                 </a:solidFill>
                 <a:latin typeface="Bahnschrift"/>
                 <a:ea typeface="Bahnschrift"/>
@@ -12711,7 +12711,7 @@
             <a:r>
               <a:rPr lang="en-US" sz="1800" dirty="0">
                 <a:solidFill>
-                  <a:srgbClr val="ACA593"/>
+                  <a:srgbClr val="DAD7CE"/>
                 </a:solidFill>
                 <a:latin typeface="Microsoft YaHei" pitchFamily="34" charset="0"/>
                 <a:ea typeface="Microsoft YaHei" pitchFamily="34" charset="-122"/>
@@ -12750,7 +12750,7 @@
             <a:r>
               <a:rPr lang="en-US" sz="1200" dirty="0">
                 <a:solidFill>
-                  <a:srgbClr val="ACA593"/>
+                  <a:srgbClr val="DAD7CE"/>
                 </a:solidFill>
                 <a:latin typeface="Bahnschrift" pitchFamily="34" charset="0"/>
                 <a:ea typeface="Bahnschrift" pitchFamily="34" charset="-122"/>
@@ -12814,7 +12814,7 @@
             <a:r>
               <a:rPr lang="en-US" sz="2800" b="1" dirty="0">
                 <a:solidFill>
-                  <a:srgbClr val="26231E"/>
+                  <a:srgbClr val="38352F"/>
                 </a:solidFill>
                 <a:latin typeface="Microsoft YaHei" pitchFamily="34" charset="0"/>
                 <a:ea typeface="Microsoft YaHei" pitchFamily="34" charset="-122"/>
@@ -12843,11 +12843,11 @@
             </a:avLst>
           </a:prstGeom>
           <a:solidFill>
-            <a:srgbClr val="26231E"/>
+            <a:srgbClr val="38352F"/>
           </a:solidFill>
           <a:ln w="12700">
             <a:solidFill>
-              <a:srgbClr val="26231E"/>
+              <a:srgbClr val="38352F"/>
             </a:solidFill>
             <a:prstDash val="solid"/>
           </a:ln>
@@ -12947,7 +12947,7 @@
                       <a:r>
                         <a:rPr lang="en-US" sz="1300" b="1" dirty="0">
                           <a:solidFill>
-                            <a:srgbClr val="26231E"/>
+                            <a:srgbClr val="38352F"/>
                           </a:solidFill>
                           <a:latin typeface="Microsoft YaHei" pitchFamily="34" charset="0"/>
                           <a:ea typeface="Microsoft YaHei" pitchFamily="34" charset="-122"/>
@@ -12971,7 +12971,7 @@
                     </a:lnR>
                     <a:lnT w="28575" cap="flat" cmpd="sng" algn="ctr">
                       <a:solidFill>
-                        <a:srgbClr val="26231E"/>
+                        <a:srgbClr val="38352F"/>
                       </a:solidFill>
                       <a:prstDash val="solid"/>
                       <a:round/>
@@ -12980,7 +12980,7 @@
                     </a:lnT>
                     <a:lnB w="9525" cap="flat" cmpd="sng" algn="ctr">
                       <a:solidFill>
-                        <a:srgbClr val="26231E"/>
+                        <a:srgbClr val="38352F"/>
                       </a:solidFill>
                       <a:prstDash val="solid"/>
                       <a:round/>
@@ -13000,7 +13000,7 @@
                       <a:r>
                         <a:rPr lang="en-US" sz="1300" b="1" dirty="0">
                           <a:solidFill>
-                            <a:srgbClr val="26231E"/>
+                            <a:srgbClr val="38352F"/>
                           </a:solidFill>
                           <a:latin typeface="Microsoft YaHei" pitchFamily="34" charset="0"/>
                           <a:ea typeface="Microsoft YaHei" pitchFamily="34" charset="-122"/>
@@ -13024,7 +13024,7 @@
                     </a:lnR>
                     <a:lnT w="28575" cap="flat" cmpd="sng" algn="ctr">
                       <a:solidFill>
-                        <a:srgbClr val="26231E"/>
+                        <a:srgbClr val="38352F"/>
                       </a:solidFill>
                       <a:prstDash val="solid"/>
                       <a:round/>
@@ -13033,7 +13033,7 @@
                     </a:lnT>
                     <a:lnB w="9525" cap="flat" cmpd="sng" algn="ctr">
                       <a:solidFill>
-                        <a:srgbClr val="26231E"/>
+                        <a:srgbClr val="38352F"/>
                       </a:solidFill>
                       <a:prstDash val="solid"/>
                       <a:round/>
@@ -13053,7 +13053,7 @@
                       <a:r>
                         <a:rPr lang="en-US" sz="1300" b="1" dirty="0">
                           <a:solidFill>
-                            <a:srgbClr val="26231E"/>
+                            <a:srgbClr val="38352F"/>
                           </a:solidFill>
                           <a:latin typeface="Microsoft YaHei" pitchFamily="34" charset="0"/>
                           <a:ea typeface="Microsoft YaHei" pitchFamily="34" charset="-122"/>
@@ -13077,7 +13077,7 @@
                     </a:lnR>
                     <a:lnT w="28575" cap="flat" cmpd="sng" algn="ctr">
                       <a:solidFill>
-                        <a:srgbClr val="26231E"/>
+                        <a:srgbClr val="38352F"/>
                       </a:solidFill>
                       <a:prstDash val="solid"/>
                       <a:round/>
@@ -13086,7 +13086,7 @@
                     </a:lnT>
                     <a:lnB w="9525" cap="flat" cmpd="sng" algn="ctr">
                       <a:solidFill>
-                        <a:srgbClr val="26231E"/>
+                        <a:srgbClr val="38352F"/>
                       </a:solidFill>
                       <a:prstDash val="solid"/>
                       <a:round/>
@@ -13106,7 +13106,7 @@
                       <a:r>
                         <a:rPr lang="en-US" sz="1300" b="1" dirty="0">
                           <a:solidFill>
-                            <a:srgbClr val="26231E"/>
+                            <a:srgbClr val="38352F"/>
                           </a:solidFill>
                           <a:latin typeface="Microsoft YaHei" pitchFamily="34" charset="0"/>
                           <a:ea typeface="Microsoft YaHei" pitchFamily="34" charset="-122"/>
@@ -13130,7 +13130,7 @@
                     </a:lnR>
                     <a:lnT w="28575" cap="flat" cmpd="sng" algn="ctr">
                       <a:solidFill>
-                        <a:srgbClr val="26231E"/>
+                        <a:srgbClr val="38352F"/>
                       </a:solidFill>
                       <a:prstDash val="solid"/>
                       <a:round/>
@@ -13139,7 +13139,7 @@
                     </a:lnT>
                     <a:lnB w="9525" cap="flat" cmpd="sng" algn="ctr">
                       <a:solidFill>
-                        <a:srgbClr val="26231E"/>
+                        <a:srgbClr val="38352F"/>
                       </a:solidFill>
                       <a:prstDash val="solid"/>
                       <a:round/>
@@ -13159,7 +13159,7 @@
                       <a:r>
                         <a:rPr lang="en-US" sz="1300" b="1" dirty="0">
                           <a:solidFill>
-                            <a:srgbClr val="26231E"/>
+                            <a:srgbClr val="38352F"/>
                           </a:solidFill>
                           <a:latin typeface="Microsoft YaHei" pitchFamily="34" charset="0"/>
                           <a:ea typeface="Microsoft YaHei" pitchFamily="34" charset="-122"/>
@@ -13183,7 +13183,7 @@
                     </a:lnR>
                     <a:lnT w="28575" cap="flat" cmpd="sng" algn="ctr">
                       <a:solidFill>
-                        <a:srgbClr val="26231E"/>
+                        <a:srgbClr val="38352F"/>
                       </a:solidFill>
                       <a:prstDash val="solid"/>
                       <a:round/>
@@ -13192,7 +13192,7 @@
                     </a:lnT>
                     <a:lnB w="9525" cap="flat" cmpd="sng" algn="ctr">
                       <a:solidFill>
-                        <a:srgbClr val="26231E"/>
+                        <a:srgbClr val="38352F"/>
                       </a:solidFill>
                       <a:prstDash val="solid"/>
                       <a:round/>
@@ -13214,7 +13214,7 @@
                       <a:r>
                         <a:rPr lang="en-US" sz="1400" dirty="0">
                           <a:solidFill>
-                            <a:srgbClr val="26231E"/>
+                            <a:srgbClr val="38352F"/>
                           </a:solidFill>
                           <a:latin typeface="Microsoft YaHei" pitchFamily="34" charset="0"/>
                           <a:ea typeface="Microsoft YaHei" pitchFamily="34" charset="-122"/>
@@ -13261,7 +13261,7 @@
                       <a:r>
                         <a:rPr lang="en-US" sz="1400" dirty="0">
                           <a:solidFill>
-                            <a:srgbClr val="6A6458"/>
+                            <a:srgbClr val="38352F"/>
                           </a:solidFill>
                           <a:latin typeface="Microsoft YaHei" pitchFamily="34" charset="0"/>
                           <a:ea typeface="Microsoft YaHei" pitchFamily="34" charset="-122"/>
@@ -13308,7 +13308,7 @@
                       <a:r>
                         <a:rPr lang="en-US" sz="1400" dirty="0">
                           <a:solidFill>
-                            <a:srgbClr val="6A6458"/>
+                            <a:srgbClr val="38352F"/>
                           </a:solidFill>
                           <a:latin typeface="Microsoft YaHei" pitchFamily="34" charset="0"/>
                           <a:ea typeface="Microsoft YaHei" pitchFamily="34" charset="-122"/>
@@ -13355,7 +13355,7 @@
                       <a:r>
                         <a:rPr lang="en-US" sz="1400" dirty="0">
                           <a:solidFill>
-                            <a:srgbClr val="6A6458"/>
+                            <a:srgbClr val="38352F"/>
                           </a:solidFill>
                           <a:latin typeface="Microsoft YaHei" pitchFamily="34" charset="0"/>
                           <a:ea typeface="Microsoft YaHei" pitchFamily="34" charset="-122"/>
@@ -13402,7 +13402,7 @@
                       <a:r>
                         <a:rPr lang="en-US" sz="1400" dirty="0">
                           <a:solidFill>
-                            <a:srgbClr val="6A6458"/>
+                            <a:srgbClr val="38352F"/>
                           </a:solidFill>
                           <a:latin typeface="Microsoft YaHei" pitchFamily="34" charset="0"/>
                           <a:ea typeface="Microsoft YaHei" pitchFamily="34" charset="-122"/>
@@ -13451,7 +13451,7 @@
                       <a:r>
                         <a:rPr lang="en-US" sz="1400" dirty="0">
                           <a:solidFill>
-                            <a:srgbClr val="26231E"/>
+                            <a:srgbClr val="38352F"/>
                           </a:solidFill>
                           <a:latin typeface="Microsoft YaHei" pitchFamily="34" charset="0"/>
                           <a:ea typeface="Microsoft YaHei" pitchFamily="34" charset="-122"/>
@@ -13498,7 +13498,7 @@
                       <a:r>
                         <a:rPr lang="en-US" sz="1400" dirty="0">
                           <a:solidFill>
-                            <a:srgbClr val="6A6458"/>
+                            <a:srgbClr val="38352F"/>
                           </a:solidFill>
                           <a:latin typeface="Microsoft YaHei" pitchFamily="34" charset="0"/>
                           <a:ea typeface="Microsoft YaHei" pitchFamily="34" charset="-122"/>
@@ -13545,7 +13545,7 @@
                       <a:r>
                         <a:rPr lang="en-US" sz="1400" dirty="0">
                           <a:solidFill>
-                            <a:srgbClr val="6A6458"/>
+                            <a:srgbClr val="38352F"/>
                           </a:solidFill>
                           <a:latin typeface="Microsoft YaHei" pitchFamily="34" charset="0"/>
                           <a:ea typeface="Microsoft YaHei" pitchFamily="34" charset="-122"/>
@@ -13592,7 +13592,7 @@
                       <a:r>
                         <a:rPr lang="en-US" sz="1400" dirty="0">
                           <a:solidFill>
-                            <a:srgbClr val="6A6458"/>
+                            <a:srgbClr val="38352F"/>
                           </a:solidFill>
                           <a:latin typeface="Microsoft YaHei" pitchFamily="34" charset="0"/>
                           <a:ea typeface="Microsoft YaHei" pitchFamily="34" charset="-122"/>
@@ -13639,7 +13639,7 @@
                       <a:r>
                         <a:rPr lang="en-US" sz="1400" dirty="0">
                           <a:solidFill>
-                            <a:srgbClr val="6A6458"/>
+                            <a:srgbClr val="38352F"/>
                           </a:solidFill>
                           <a:latin typeface="Microsoft YaHei" pitchFamily="34" charset="0"/>
                           <a:ea typeface="Microsoft YaHei" pitchFamily="34" charset="-122"/>
@@ -13688,7 +13688,7 @@
                       <a:r>
                         <a:rPr lang="en-US" sz="1400" dirty="0">
                           <a:solidFill>
-                            <a:srgbClr val="26231E"/>
+                            <a:srgbClr val="38352F"/>
                           </a:solidFill>
                           <a:latin typeface="Microsoft YaHei" pitchFamily="34" charset="0"/>
                           <a:ea typeface="Microsoft YaHei" pitchFamily="34" charset="-122"/>
@@ -13735,7 +13735,7 @@
                       <a:r>
                         <a:rPr lang="en-US" sz="1400" dirty="0">
                           <a:solidFill>
-                            <a:srgbClr val="6A6458"/>
+                            <a:srgbClr val="38352F"/>
                           </a:solidFill>
                           <a:latin typeface="Microsoft YaHei" pitchFamily="34" charset="0"/>
                           <a:ea typeface="Microsoft YaHei" pitchFamily="34" charset="-122"/>
@@ -13782,7 +13782,7 @@
                       <a:r>
                         <a:rPr lang="en-US" sz="1400" dirty="0">
                           <a:solidFill>
-                            <a:srgbClr val="6A6458"/>
+                            <a:srgbClr val="38352F"/>
                           </a:solidFill>
                           <a:latin typeface="Microsoft YaHei" pitchFamily="34" charset="0"/>
                           <a:ea typeface="Microsoft YaHei" pitchFamily="34" charset="-122"/>
@@ -13829,7 +13829,7 @@
                       <a:r>
                         <a:rPr lang="en-US" sz="1400" dirty="0">
                           <a:solidFill>
-                            <a:srgbClr val="6A6458"/>
+                            <a:srgbClr val="38352F"/>
                           </a:solidFill>
                           <a:latin typeface="Microsoft YaHei" pitchFamily="34" charset="0"/>
                           <a:ea typeface="Microsoft YaHei" pitchFamily="34" charset="-122"/>
@@ -13876,7 +13876,7 @@
                       <a:r>
                         <a:rPr lang="en-US" sz="1400" dirty="0">
                           <a:solidFill>
-                            <a:srgbClr val="6A6458"/>
+                            <a:srgbClr val="38352F"/>
                           </a:solidFill>
                           <a:latin typeface="Microsoft YaHei" pitchFamily="34" charset="0"/>
                           <a:ea typeface="Microsoft YaHei" pitchFamily="34" charset="-122"/>
@@ -13925,7 +13925,7 @@
                       <a:r>
                         <a:rPr lang="en-US" sz="1400" dirty="0">
                           <a:solidFill>
-                            <a:srgbClr val="26231E"/>
+                            <a:srgbClr val="38352F"/>
                           </a:solidFill>
                           <a:latin typeface="Microsoft YaHei" pitchFamily="34" charset="0"/>
                           <a:ea typeface="Microsoft YaHei" pitchFamily="34" charset="-122"/>
@@ -13952,7 +13952,7 @@
                     </a:lnT>
                     <a:lnB w="12700" cap="flat" cmpd="sng" algn="ctr">
                       <a:solidFill>
-                        <a:srgbClr val="26231E"/>
+                        <a:srgbClr val="38352F"/>
                       </a:solidFill>
                       <a:prstDash val="solid"/>
                       <a:round/>
@@ -13972,7 +13972,7 @@
                       <a:r>
                         <a:rPr lang="en-US" sz="1400" dirty="0">
                           <a:solidFill>
-                            <a:srgbClr val="6A6458"/>
+                            <a:srgbClr val="38352F"/>
                           </a:solidFill>
                           <a:latin typeface="Microsoft YaHei" pitchFamily="34" charset="0"/>
                           <a:ea typeface="Microsoft YaHei" pitchFamily="34" charset="-122"/>
@@ -13999,7 +13999,7 @@
                     </a:lnT>
                     <a:lnB w="12700" cap="flat" cmpd="sng" algn="ctr">
                       <a:solidFill>
-                        <a:srgbClr val="26231E"/>
+                        <a:srgbClr val="38352F"/>
                       </a:solidFill>
                       <a:prstDash val="solid"/>
                       <a:round/>
@@ -14019,7 +14019,7 @@
                       <a:r>
                         <a:rPr lang="en-US" sz="1400" dirty="0">
                           <a:solidFill>
-                            <a:srgbClr val="6A6458"/>
+                            <a:srgbClr val="38352F"/>
                           </a:solidFill>
                           <a:latin typeface="Microsoft YaHei" pitchFamily="34" charset="0"/>
                           <a:ea typeface="Microsoft YaHei" pitchFamily="34" charset="-122"/>
@@ -14046,7 +14046,7 @@
                     </a:lnT>
                     <a:lnB w="12700" cap="flat" cmpd="sng" algn="ctr">
                       <a:solidFill>
-                        <a:srgbClr val="26231E"/>
+                        <a:srgbClr val="38352F"/>
                       </a:solidFill>
                       <a:prstDash val="solid"/>
                       <a:round/>
@@ -14066,7 +14066,7 @@
                       <a:r>
                         <a:rPr lang="en-US" sz="1400" dirty="0">
                           <a:solidFill>
-                            <a:srgbClr val="6A6458"/>
+                            <a:srgbClr val="38352F"/>
                           </a:solidFill>
                           <a:latin typeface="Microsoft YaHei" pitchFamily="34" charset="0"/>
                           <a:ea typeface="Microsoft YaHei" pitchFamily="34" charset="-122"/>
@@ -14093,7 +14093,7 @@
                     </a:lnT>
                     <a:lnB w="12700" cap="flat" cmpd="sng" algn="ctr">
                       <a:solidFill>
-                        <a:srgbClr val="26231E"/>
+                        <a:srgbClr val="38352F"/>
                       </a:solidFill>
                       <a:prstDash val="solid"/>
                       <a:round/>
@@ -14113,7 +14113,7 @@
                       <a:r>
                         <a:rPr lang="en-US" sz="1400" dirty="0">
                           <a:solidFill>
-                            <a:srgbClr val="6A6458"/>
+                            <a:srgbClr val="38352F"/>
                           </a:solidFill>
                           <a:latin typeface="Microsoft YaHei" pitchFamily="34" charset="0"/>
                           <a:ea typeface="Microsoft YaHei" pitchFamily="34" charset="-122"/>
@@ -14140,7 +14140,7 @@
                     </a:lnT>
                     <a:lnB w="12700" cap="flat" cmpd="sng" algn="ctr">
                       <a:solidFill>
-                        <a:srgbClr val="26231E"/>
+                        <a:srgbClr val="38352F"/>
                       </a:solidFill>
                       <a:prstDash val="solid"/>
                       <a:round/>
@@ -14184,7 +14184,7 @@
             <a:lvl1pPr>
               <a:defRPr sz="1200">
                 <a:solidFill>
-                  <a:srgbClr val="26231E"/>
+                  <a:srgbClr val="38352F"/>
                 </a:solidFill>
                 <a:latin typeface="Bahnschrift"/>
                 <a:ea typeface="Bahnschrift"/>
@@ -14254,7 +14254,7 @@
             <a:r>
               <a:rPr lang="en-US" sz="2800" b="1" dirty="0">
                 <a:solidFill>
-                  <a:srgbClr val="26231E"/>
+                  <a:srgbClr val="38352F"/>
                 </a:solidFill>
                 <a:latin typeface="Microsoft YaHei" pitchFamily="34" charset="0"/>
                 <a:ea typeface="Microsoft YaHei" pitchFamily="34" charset="-122"/>
@@ -14283,11 +14283,11 @@
             </a:avLst>
           </a:prstGeom>
           <a:solidFill>
-            <a:srgbClr val="26231E"/>
+            <a:srgbClr val="38352F"/>
           </a:solidFill>
           <a:ln w="12700">
             <a:solidFill>
-              <a:srgbClr val="26231E"/>
+              <a:srgbClr val="38352F"/>
             </a:solidFill>
             <a:prstDash val="solid"/>
           </a:ln>
@@ -14361,11 +14361,11 @@
             <a:avLst/>
           </a:prstGeom>
           <a:solidFill>
-            <a:srgbClr val="26231E"/>
+            <a:srgbClr val="38352F"/>
           </a:solidFill>
           <a:ln w="12700">
             <a:solidFill>
-              <a:srgbClr val="26231E"/>
+              <a:srgbClr val="38352F"/>
             </a:solidFill>
             <a:prstDash val="solid"/>
           </a:ln>
@@ -14388,11 +14388,11 @@
             </a:avLst>
           </a:prstGeom>
           <a:solidFill>
-            <a:srgbClr val="26231E"/>
+            <a:srgbClr val="38352F"/>
           </a:solidFill>
           <a:ln w="12700">
             <a:solidFill>
-              <a:srgbClr val="26231E"/>
+              <a:srgbClr val="38352F"/>
             </a:solidFill>
             <a:prstDash val="solid"/>
           </a:ln>
@@ -14425,7 +14425,7 @@
             <a:r>
               <a:rPr lang="en-US" sz="2200" b="1" dirty="0">
                 <a:solidFill>
-                  <a:srgbClr val="26231E"/>
+                  <a:srgbClr val="38352F"/>
                 </a:solidFill>
                 <a:latin typeface="Bahnschrift" pitchFamily="34" charset="0"/>
                 <a:ea typeface="Bahnschrift" pitchFamily="34" charset="-122"/>
@@ -14464,7 +14464,7 @@
             <a:r>
               <a:rPr lang="en-US" sz="1800" b="1" dirty="0">
                 <a:solidFill>
-                  <a:srgbClr val="26231E"/>
+                  <a:srgbClr val="38352F"/>
                 </a:solidFill>
                 <a:latin typeface="Microsoft YaHei" pitchFamily="34" charset="0"/>
                 <a:ea typeface="Microsoft YaHei" pitchFamily="34" charset="-122"/>
@@ -14503,7 +14503,7 @@
             <a:r>
               <a:rPr lang="en-US" sz="1300" dirty="0">
                 <a:solidFill>
-                  <a:srgbClr val="6A6458"/>
+                  <a:srgbClr val="38352F"/>
                 </a:solidFill>
                 <a:latin typeface="Bahnschrift" pitchFamily="34" charset="0"/>
                 <a:ea typeface="Bahnschrift" pitchFamily="34" charset="-122"/>
@@ -14545,7 +14545,7 @@
             <a:r>
               <a:rPr lang="en-US" sz="1200" dirty="0">
                 <a:solidFill>
-                  <a:srgbClr val="6A6458"/>
+                  <a:srgbClr val="38352F"/>
                 </a:solidFill>
                 <a:latin typeface="Microsoft YaHei" pitchFamily="34" charset="0"/>
                 <a:ea typeface="Microsoft YaHei" pitchFamily="34" charset="-122"/>
@@ -14574,11 +14574,11 @@
             </a:avLst>
           </a:prstGeom>
           <a:solidFill>
-            <a:srgbClr val="26231E"/>
+            <a:srgbClr val="38352F"/>
           </a:solidFill>
           <a:ln w="12700">
             <a:solidFill>
-              <a:srgbClr val="26231E"/>
+              <a:srgbClr val="38352F"/>
             </a:solidFill>
             <a:prstDash val="solid"/>
           </a:ln>
@@ -14611,7 +14611,7 @@
             <a:r>
               <a:rPr lang="en-US" sz="2200" b="1" dirty="0">
                 <a:solidFill>
-                  <a:srgbClr val="26231E"/>
+                  <a:srgbClr val="38352F"/>
                 </a:solidFill>
                 <a:latin typeface="Bahnschrift" pitchFamily="34" charset="0"/>
                 <a:ea typeface="Bahnschrift" pitchFamily="34" charset="-122"/>
@@ -14650,7 +14650,7 @@
             <a:r>
               <a:rPr lang="en-US" sz="1800" b="1" dirty="0">
                 <a:solidFill>
-                  <a:srgbClr val="26231E"/>
+                  <a:srgbClr val="38352F"/>
                 </a:solidFill>
                 <a:latin typeface="Microsoft YaHei" pitchFamily="34" charset="0"/>
                 <a:ea typeface="Microsoft YaHei" pitchFamily="34" charset="-122"/>
@@ -14689,7 +14689,7 @@
             <a:r>
               <a:rPr lang="en-US" sz="1300" dirty="0">
                 <a:solidFill>
-                  <a:srgbClr val="6A6458"/>
+                  <a:srgbClr val="38352F"/>
                 </a:solidFill>
                 <a:latin typeface="Bahnschrift" pitchFamily="34" charset="0"/>
                 <a:ea typeface="Bahnschrift" pitchFamily="34" charset="-122"/>
@@ -14731,7 +14731,7 @@
             <a:r>
               <a:rPr lang="en-US" sz="1200" dirty="0">
                 <a:solidFill>
-                  <a:srgbClr val="6A6458"/>
+                  <a:srgbClr val="38352F"/>
                 </a:solidFill>
                 <a:latin typeface="Microsoft YaHei" pitchFamily="34" charset="0"/>
                 <a:ea typeface="Microsoft YaHei" pitchFamily="34" charset="-122"/>
@@ -14760,11 +14760,11 @@
             </a:avLst>
           </a:prstGeom>
           <a:solidFill>
-            <a:srgbClr val="26231E"/>
+            <a:srgbClr val="38352F"/>
           </a:solidFill>
           <a:ln w="12700">
             <a:solidFill>
-              <a:srgbClr val="26231E"/>
+              <a:srgbClr val="38352F"/>
             </a:solidFill>
             <a:prstDash val="solid"/>
           </a:ln>
@@ -14797,7 +14797,7 @@
             <a:r>
               <a:rPr lang="en-US" sz="2200" b="1" dirty="0">
                 <a:solidFill>
-                  <a:srgbClr val="26231E"/>
+                  <a:srgbClr val="38352F"/>
                 </a:solidFill>
                 <a:latin typeface="Bahnschrift" pitchFamily="34" charset="0"/>
                 <a:ea typeface="Bahnschrift" pitchFamily="34" charset="-122"/>
@@ -14836,7 +14836,7 @@
             <a:r>
               <a:rPr lang="en-US" sz="1800" b="1" dirty="0">
                 <a:solidFill>
-                  <a:srgbClr val="26231E"/>
+                  <a:srgbClr val="38352F"/>
                 </a:solidFill>
                 <a:latin typeface="Microsoft YaHei" pitchFamily="34" charset="0"/>
                 <a:ea typeface="Microsoft YaHei" pitchFamily="34" charset="-122"/>
@@ -14875,7 +14875,7 @@
             <a:r>
               <a:rPr lang="en-US" sz="1300" dirty="0">
                 <a:solidFill>
-                  <a:srgbClr val="6A6458"/>
+                  <a:srgbClr val="38352F"/>
                 </a:solidFill>
                 <a:latin typeface="Bahnschrift" pitchFamily="34" charset="0"/>
                 <a:ea typeface="Bahnschrift" pitchFamily="34" charset="-122"/>
@@ -14917,7 +14917,7 @@
             <a:r>
               <a:rPr lang="en-US" sz="1200" dirty="0">
                 <a:solidFill>
-                  <a:srgbClr val="6A6458"/>
+                  <a:srgbClr val="38352F"/>
                 </a:solidFill>
                 <a:latin typeface="Microsoft YaHei" pitchFamily="34" charset="0"/>
                 <a:ea typeface="Microsoft YaHei" pitchFamily="34" charset="-122"/>
@@ -14946,11 +14946,11 @@
             </a:avLst>
           </a:prstGeom>
           <a:solidFill>
-            <a:srgbClr val="26231E"/>
+            <a:srgbClr val="38352F"/>
           </a:solidFill>
           <a:ln w="12700">
             <a:solidFill>
-              <a:srgbClr val="26231E"/>
+              <a:srgbClr val="38352F"/>
             </a:solidFill>
             <a:prstDash val="solid"/>
           </a:ln>
@@ -14983,7 +14983,7 @@
             <a:r>
               <a:rPr lang="en-US" sz="2200" b="1" dirty="0">
                 <a:solidFill>
-                  <a:srgbClr val="26231E"/>
+                  <a:srgbClr val="38352F"/>
                 </a:solidFill>
                 <a:latin typeface="Bahnschrift" pitchFamily="34" charset="0"/>
                 <a:ea typeface="Bahnschrift" pitchFamily="34" charset="-122"/>
@@ -15022,7 +15022,7 @@
             <a:r>
               <a:rPr lang="en-US" sz="1800" b="1" dirty="0">
                 <a:solidFill>
-                  <a:srgbClr val="26231E"/>
+                  <a:srgbClr val="38352F"/>
                 </a:solidFill>
                 <a:latin typeface="Microsoft YaHei" pitchFamily="34" charset="0"/>
                 <a:ea typeface="Microsoft YaHei" pitchFamily="34" charset="-122"/>
@@ -15061,7 +15061,7 @@
             <a:r>
               <a:rPr lang="en-US" sz="1300" dirty="0">
                 <a:solidFill>
-                  <a:srgbClr val="6A6458"/>
+                  <a:srgbClr val="38352F"/>
                 </a:solidFill>
                 <a:latin typeface="Bahnschrift" pitchFamily="34" charset="0"/>
                 <a:ea typeface="Bahnschrift" pitchFamily="34" charset="-122"/>
@@ -15103,7 +15103,7 @@
             <a:r>
               <a:rPr lang="en-US" sz="1200" dirty="0">
                 <a:solidFill>
-                  <a:srgbClr val="6A6458"/>
+                  <a:srgbClr val="38352F"/>
                 </a:solidFill>
                 <a:latin typeface="Microsoft YaHei" pitchFamily="34" charset="0"/>
                 <a:ea typeface="Microsoft YaHei" pitchFamily="34" charset="-122"/>
@@ -15145,7 +15145,7 @@
             <a:lvl1pPr>
               <a:defRPr sz="1200">
                 <a:solidFill>
-                  <a:srgbClr val="26231E"/>
+                  <a:srgbClr val="38352F"/>
                 </a:solidFill>
                 <a:latin typeface="Bahnschrift"/>
                 <a:ea typeface="Bahnschrift"/>
@@ -15215,7 +15215,7 @@
             <a:r>
               <a:rPr lang="en-US" sz="2800" b="1" dirty="0">
                 <a:solidFill>
-                  <a:srgbClr val="26231E"/>
+                  <a:srgbClr val="38352F"/>
                 </a:solidFill>
                 <a:latin typeface="Microsoft YaHei" pitchFamily="34" charset="0"/>
                 <a:ea typeface="Microsoft YaHei" pitchFamily="34" charset="-122"/>
@@ -15244,11 +15244,11 @@
             </a:avLst>
           </a:prstGeom>
           <a:solidFill>
-            <a:srgbClr val="26231E"/>
+            <a:srgbClr val="38352F"/>
           </a:solidFill>
           <a:ln w="12700">
             <a:solidFill>
-              <a:srgbClr val="26231E"/>
+              <a:srgbClr val="38352F"/>
             </a:solidFill>
             <a:prstDash val="solid"/>
           </a:ln>
@@ -15341,7 +15341,7 @@
             <a:r>
               <a:rPr lang="en-US" sz="1600" dirty="0">
                 <a:solidFill>
-                  <a:srgbClr val="26231E"/>
+                  <a:srgbClr val="38352F"/>
                 </a:solidFill>
                 <a:latin typeface="Microsoft YaHei" pitchFamily="34" charset="0"/>
                 <a:ea typeface="Microsoft YaHei" pitchFamily="34" charset="-122"/>
@@ -15365,7 +15365,7 @@
             <a:r>
               <a:rPr lang="en-US" sz="1600" dirty="0">
                 <a:solidFill>
-                  <a:srgbClr val="26231E"/>
+                  <a:srgbClr val="38352F"/>
                 </a:solidFill>
                 <a:latin typeface="Microsoft YaHei" pitchFamily="34" charset="0"/>
                 <a:ea typeface="Microsoft YaHei" pitchFamily="34" charset="-122"/>
@@ -15389,7 +15389,7 @@
             <a:r>
               <a:rPr lang="en-US" sz="1600" dirty="0">
                 <a:solidFill>
-                  <a:srgbClr val="26231E"/>
+                  <a:srgbClr val="38352F"/>
                 </a:solidFill>
                 <a:latin typeface="Microsoft YaHei" pitchFamily="34" charset="0"/>
                 <a:ea typeface="Microsoft YaHei" pitchFamily="34" charset="-122"/>
@@ -15413,7 +15413,7 @@
             <a:r>
               <a:rPr lang="en-US" sz="1600" dirty="0">
                 <a:solidFill>
-                  <a:srgbClr val="26231E"/>
+                  <a:srgbClr val="38352F"/>
                 </a:solidFill>
                 <a:latin typeface="Microsoft YaHei" pitchFamily="34" charset="0"/>
                 <a:ea typeface="Microsoft YaHei" pitchFamily="34" charset="-122"/>
@@ -15479,7 +15479,7 @@
             <a:r>
               <a:rPr lang="en-US" sz="1200" dirty="0">
                 <a:solidFill>
-                  <a:srgbClr val="6A6458"/>
+                  <a:srgbClr val="38352F"/>
                 </a:solidFill>
                 <a:latin typeface="Microsoft YaHei" pitchFamily="34" charset="0"/>
                 <a:ea typeface="Microsoft YaHei" pitchFamily="34" charset="-122"/>
@@ -15521,7 +15521,7 @@
             <a:lvl1pPr>
               <a:defRPr sz="1200">
                 <a:solidFill>
-                  <a:srgbClr val="26231E"/>
+                  <a:srgbClr val="38352F"/>
                 </a:solidFill>
                 <a:latin typeface="Bahnschrift"/>
                 <a:ea typeface="Bahnschrift"/>
@@ -15591,7 +15591,7 @@
             <a:r>
               <a:rPr lang="en-US" sz="2800" b="1" dirty="0">
                 <a:solidFill>
-                  <a:srgbClr val="26231E"/>
+                  <a:srgbClr val="38352F"/>
                 </a:solidFill>
                 <a:latin typeface="Microsoft YaHei" pitchFamily="34" charset="0"/>
                 <a:ea typeface="Microsoft YaHei" pitchFamily="34" charset="-122"/>
@@ -15620,11 +15620,11 @@
             </a:avLst>
           </a:prstGeom>
           <a:solidFill>
-            <a:srgbClr val="26231E"/>
+            <a:srgbClr val="38352F"/>
           </a:solidFill>
           <a:ln w="12700">
             <a:solidFill>
-              <a:srgbClr val="26231E"/>
+              <a:srgbClr val="38352F"/>
             </a:solidFill>
             <a:prstDash val="solid"/>
           </a:ln>
@@ -15698,11 +15698,11 @@
             <a:avLst/>
           </a:prstGeom>
           <a:solidFill>
-            <a:srgbClr val="26231E"/>
+            <a:srgbClr val="38352F"/>
           </a:solidFill>
           <a:ln w="12700">
             <a:solidFill>
-              <a:srgbClr val="26231E"/>
+              <a:srgbClr val="38352F"/>
             </a:solidFill>
             <a:prstDash val="solid"/>
           </a:ln>
@@ -15735,7 +15735,7 @@
             <a:r>
               <a:rPr lang="en-US" sz="1600" b="1" dirty="0">
                 <a:solidFill>
-                  <a:srgbClr val="26231E"/>
+                  <a:srgbClr val="38352F"/>
                 </a:solidFill>
                 <a:latin typeface="Bahnschrift" pitchFamily="34" charset="0"/>
                 <a:ea typeface="Bahnschrift" pitchFamily="34" charset="-122"/>
@@ -15774,7 +15774,7 @@
             <a:r>
               <a:rPr lang="en-US" sz="1800" b="1" dirty="0">
                 <a:solidFill>
-                  <a:srgbClr val="26231E"/>
+                  <a:srgbClr val="38352F"/>
                 </a:solidFill>
                 <a:latin typeface="Microsoft YaHei" pitchFamily="34" charset="0"/>
                 <a:ea typeface="Microsoft YaHei" pitchFamily="34" charset="-122"/>
@@ -15816,7 +15816,7 @@
             <a:r>
               <a:rPr lang="en-US" sz="1300" dirty="0">
                 <a:solidFill>
-                  <a:srgbClr val="6A6458"/>
+                  <a:srgbClr val="38352F"/>
                 </a:solidFill>
                 <a:latin typeface="Microsoft YaHei" pitchFamily="34" charset="0"/>
                 <a:ea typeface="Microsoft YaHei" pitchFamily="34" charset="-122"/>
@@ -15843,11 +15843,11 @@
             <a:avLst/>
           </a:prstGeom>
           <a:solidFill>
-            <a:srgbClr val="26231E"/>
+            <a:srgbClr val="38352F"/>
           </a:solidFill>
           <a:ln w="12700">
             <a:solidFill>
-              <a:srgbClr val="26231E"/>
+              <a:srgbClr val="38352F"/>
             </a:solidFill>
             <a:prstDash val="solid"/>
           </a:ln>
@@ -15880,7 +15880,7 @@
             <a:r>
               <a:rPr lang="en-US" sz="1600" b="1" dirty="0">
                 <a:solidFill>
-                  <a:srgbClr val="26231E"/>
+                  <a:srgbClr val="38352F"/>
                 </a:solidFill>
                 <a:latin typeface="Bahnschrift" pitchFamily="34" charset="0"/>
                 <a:ea typeface="Bahnschrift" pitchFamily="34" charset="-122"/>
@@ -15919,7 +15919,7 @@
             <a:r>
               <a:rPr lang="en-US" sz="1800" b="1" dirty="0">
                 <a:solidFill>
-                  <a:srgbClr val="26231E"/>
+                  <a:srgbClr val="38352F"/>
                 </a:solidFill>
                 <a:latin typeface="Microsoft YaHei" pitchFamily="34" charset="0"/>
                 <a:ea typeface="Microsoft YaHei" pitchFamily="34" charset="-122"/>
@@ -15961,7 +15961,7 @@
             <a:r>
               <a:rPr lang="en-US" sz="1300" dirty="0">
                 <a:solidFill>
-                  <a:srgbClr val="6A6458"/>
+                  <a:srgbClr val="38352F"/>
                 </a:solidFill>
                 <a:latin typeface="Microsoft YaHei" pitchFamily="34" charset="0"/>
                 <a:ea typeface="Microsoft YaHei" pitchFamily="34" charset="-122"/>
@@ -15988,11 +15988,11 @@
             <a:avLst/>
           </a:prstGeom>
           <a:solidFill>
-            <a:srgbClr val="26231E"/>
+            <a:srgbClr val="38352F"/>
           </a:solidFill>
           <a:ln w="12700">
             <a:solidFill>
-              <a:srgbClr val="26231E"/>
+              <a:srgbClr val="38352F"/>
             </a:solidFill>
             <a:prstDash val="solid"/>
           </a:ln>
@@ -16025,7 +16025,7 @@
             <a:r>
               <a:rPr lang="en-US" sz="1600" b="1" dirty="0">
                 <a:solidFill>
-                  <a:srgbClr val="26231E"/>
+                  <a:srgbClr val="38352F"/>
                 </a:solidFill>
                 <a:latin typeface="Bahnschrift" pitchFamily="34" charset="0"/>
                 <a:ea typeface="Bahnschrift" pitchFamily="34" charset="-122"/>
@@ -16064,7 +16064,7 @@
             <a:r>
               <a:rPr lang="en-US" sz="1800" b="1" dirty="0">
                 <a:solidFill>
-                  <a:srgbClr val="26231E"/>
+                  <a:srgbClr val="38352F"/>
                 </a:solidFill>
                 <a:latin typeface="Microsoft YaHei" pitchFamily="34" charset="0"/>
                 <a:ea typeface="Microsoft YaHei" pitchFamily="34" charset="-122"/>
@@ -16106,7 +16106,7 @@
             <a:r>
               <a:rPr lang="en-US" sz="1300" dirty="0">
                 <a:solidFill>
-                  <a:srgbClr val="6A6458"/>
+                  <a:srgbClr val="38352F"/>
                 </a:solidFill>
                 <a:latin typeface="Microsoft YaHei" pitchFamily="34" charset="0"/>
                 <a:ea typeface="Microsoft YaHei" pitchFamily="34" charset="-122"/>
@@ -16148,7 +16148,7 @@
             <a:lvl1pPr>
               <a:defRPr sz="1200">
                 <a:solidFill>
-                  <a:srgbClr val="26231E"/>
+                  <a:srgbClr val="38352F"/>
                 </a:solidFill>
                 <a:latin typeface="Bahnschrift"/>
                 <a:ea typeface="Bahnschrift"/>
@@ -16296,7 +16296,7 @@
             <a:r>
               <a:rPr lang="en-US" sz="1800" dirty="0">
                 <a:solidFill>
-                  <a:srgbClr val="ACA593"/>
+                  <a:srgbClr val="DAD7CE"/>
                 </a:solidFill>
                 <a:latin typeface="Microsoft YaHei" pitchFamily="34" charset="0"/>
                 <a:ea typeface="Microsoft YaHei" pitchFamily="34" charset="-122"/>
@@ -16335,7 +16335,7 @@
             <a:r>
               <a:rPr lang="en-US" sz="1200" dirty="0">
                 <a:solidFill>
-                  <a:srgbClr val="ACA593"/>
+                  <a:srgbClr val="DAD7CE"/>
                 </a:solidFill>
                 <a:latin typeface="Bahnschrift" pitchFamily="34" charset="0"/>
                 <a:ea typeface="Bahnschrift" pitchFamily="34" charset="-122"/>
@@ -16399,7 +16399,7 @@
             <a:r>
               <a:rPr lang="en-US" sz="2800" b="1" dirty="0">
                 <a:solidFill>
-                  <a:srgbClr val="26231E"/>
+                  <a:srgbClr val="38352F"/>
                 </a:solidFill>
                 <a:latin typeface="Microsoft YaHei" pitchFamily="34" charset="0"/>
                 <a:ea typeface="Microsoft YaHei" pitchFamily="34" charset="-122"/>
@@ -16428,11 +16428,11 @@
             </a:avLst>
           </a:prstGeom>
           <a:solidFill>
-            <a:srgbClr val="26231E"/>
+            <a:srgbClr val="38352F"/>
           </a:solidFill>
           <a:ln w="12700">
             <a:solidFill>
-              <a:srgbClr val="26231E"/>
+              <a:srgbClr val="38352F"/>
             </a:solidFill>
             <a:prstDash val="solid"/>
           </a:ln>
@@ -16518,7 +16518,7 @@
             <a:r>
               <a:rPr lang="en-US" sz="6600" b="1" dirty="0">
                 <a:solidFill>
-                  <a:srgbClr val="26231E"/>
+                  <a:srgbClr val="38352F"/>
                 </a:solidFill>
                 <a:latin typeface="Bahnschrift" pitchFamily="34" charset="0"/>
                 <a:ea typeface="Bahnschrift" pitchFamily="34" charset="-122"/>
@@ -16557,7 +16557,7 @@
             <a:r>
               <a:rPr lang="en-US" sz="1800" b="1" dirty="0">
                 <a:solidFill>
-                  <a:srgbClr val="26231E"/>
+                  <a:srgbClr val="38352F"/>
                 </a:solidFill>
                 <a:latin typeface="Microsoft YaHei" pitchFamily="34" charset="0"/>
                 <a:ea typeface="Microsoft YaHei" pitchFamily="34" charset="-122"/>
@@ -16599,7 +16599,7 @@
             <a:r>
               <a:rPr lang="en-US" sz="1300" dirty="0">
                 <a:solidFill>
-                  <a:srgbClr val="6A6458"/>
+                  <a:srgbClr val="38352F"/>
                 </a:solidFill>
                 <a:latin typeface="Microsoft YaHei" pitchFamily="34" charset="0"/>
                 <a:ea typeface="Microsoft YaHei" pitchFamily="34" charset="-122"/>
@@ -16661,7 +16661,7 @@
             <a:r>
               <a:rPr lang="en-US" sz="6600" b="1" dirty="0">
                 <a:solidFill>
-                  <a:srgbClr val="26231E"/>
+                  <a:srgbClr val="38352F"/>
                 </a:solidFill>
                 <a:latin typeface="Bahnschrift" pitchFamily="34" charset="0"/>
                 <a:ea typeface="Bahnschrift" pitchFamily="34" charset="-122"/>
@@ -16700,7 +16700,7 @@
             <a:r>
               <a:rPr lang="en-US" sz="1800" b="1" dirty="0">
                 <a:solidFill>
-                  <a:srgbClr val="26231E"/>
+                  <a:srgbClr val="38352F"/>
                 </a:solidFill>
                 <a:latin typeface="Microsoft YaHei" pitchFamily="34" charset="0"/>
                 <a:ea typeface="Microsoft YaHei" pitchFamily="34" charset="-122"/>
@@ -16742,7 +16742,7 @@
             <a:r>
               <a:rPr lang="en-US" sz="1300" dirty="0">
                 <a:solidFill>
-                  <a:srgbClr val="6A6458"/>
+                  <a:srgbClr val="38352F"/>
                 </a:solidFill>
                 <a:latin typeface="Microsoft YaHei" pitchFamily="34" charset="0"/>
                 <a:ea typeface="Microsoft YaHei" pitchFamily="34" charset="-122"/>
@@ -16804,7 +16804,7 @@
             <a:r>
               <a:rPr lang="en-US" sz="6600" b="1" dirty="0">
                 <a:solidFill>
-                  <a:srgbClr val="26231E"/>
+                  <a:srgbClr val="38352F"/>
                 </a:solidFill>
                 <a:latin typeface="Bahnschrift" pitchFamily="34" charset="0"/>
                 <a:ea typeface="Bahnschrift" pitchFamily="34" charset="-122"/>
@@ -16843,7 +16843,7 @@
             <a:r>
               <a:rPr lang="en-US" sz="1800" b="1" dirty="0">
                 <a:solidFill>
-                  <a:srgbClr val="26231E"/>
+                  <a:srgbClr val="38352F"/>
                 </a:solidFill>
                 <a:latin typeface="Microsoft YaHei" pitchFamily="34" charset="0"/>
                 <a:ea typeface="Microsoft YaHei" pitchFamily="34" charset="-122"/>
@@ -16885,7 +16885,7 @@
             <a:r>
               <a:rPr lang="en-US" sz="1300" dirty="0">
                 <a:solidFill>
-                  <a:srgbClr val="6A6458"/>
+                  <a:srgbClr val="38352F"/>
                 </a:solidFill>
                 <a:latin typeface="Microsoft YaHei" pitchFamily="34" charset="0"/>
                 <a:ea typeface="Microsoft YaHei" pitchFamily="34" charset="-122"/>
@@ -16927,7 +16927,7 @@
             <a:lvl1pPr>
               <a:defRPr sz="1200">
                 <a:solidFill>
-                  <a:srgbClr val="26231E"/>
+                  <a:srgbClr val="38352F"/>
                 </a:solidFill>
                 <a:latin typeface="Bahnschrift"/>
                 <a:ea typeface="Bahnschrift"/>

</xml_diff>